<commit_message>
Add real AWS deployment screenshots to presentation and report
- Captured 9 live screenshots from deployed app at 13.206.252.215:8501
  using Playwright headless browser
- Slide 9 of ClaimIQ_Presentation.pptx: replaced mock screen mockups
  with 5 real app screenshots (home, pipeline, recommendation, history, about)
- Section 11 of ClaimIQ_Project_Report.docx: added real screenshots
  under new subsection 11.1 (Live Application Screenshots - AWS EC2)
- Added scripts: capture_screenshots.py and embed_screenshots.py

Co-Authored-By: Claude Sonnet 4.6 <noreply@anthropic.com>
</commit_message>
<xml_diff>
--- a/ClaimIQ_Presentation.pptx
+++ b/ClaimIQ_Presentation.pptx
@@ -19943,472 +19943,6 @@
       </p:sp>
       <p:sp>
         <p:nvSpPr>
-          <p:cNvPr id="8" name="Rectangle 7"/>
-          <p:cNvSpPr/>
-          <p:nvPr/>
-        </p:nvSpPr>
-        <p:spPr>
-          <a:xfrm>
-            <a:off x="329184" y="1243584"/>
-            <a:ext cx="2130552" cy="164592"/>
-          </a:xfrm>
-          <a:prstGeom prst="rect">
-            <a:avLst/>
-          </a:prstGeom>
-          <a:solidFill>
-            <a:srgbClr val="0A6EBD"/>
-          </a:solidFill>
-          <a:ln>
-            <a:noFill/>
-          </a:ln>
-        </p:spPr>
-        <p:style>
-          <a:lnRef idx="1">
-            <a:schemeClr val="accent1"/>
-          </a:lnRef>
-          <a:fillRef idx="3">
-            <a:schemeClr val="accent1"/>
-          </a:fillRef>
-          <a:effectRef idx="2">
-            <a:schemeClr val="accent1"/>
-          </a:effectRef>
-          <a:fontRef idx="minor">
-            <a:schemeClr val="lt1"/>
-          </a:fontRef>
-        </p:style>
-        <p:txBody>
-          <a:bodyPr rtlCol="0" anchor="ctr"/>
-          <a:lstStyle/>
-          <a:p>
-            <a:pPr algn="ctr"/>
-          </a:p>
-        </p:txBody>
-      </p:sp>
-      <p:sp>
-        <p:nvSpPr>
-          <p:cNvPr id="9" name="Rectangle 8"/>
-          <p:cNvSpPr/>
-          <p:nvPr/>
-        </p:nvSpPr>
-        <p:spPr>
-          <a:xfrm>
-            <a:off x="356616" y="1271016"/>
-            <a:ext cx="64008" cy="64008"/>
-          </a:xfrm>
-          <a:prstGeom prst="rect">
-            <a:avLst/>
-          </a:prstGeom>
-          <a:solidFill>
-            <a:srgbClr val="FFFFFF"/>
-          </a:solidFill>
-          <a:ln>
-            <a:noFill/>
-          </a:ln>
-        </p:spPr>
-        <p:style>
-          <a:lnRef idx="1">
-            <a:schemeClr val="accent1"/>
-          </a:lnRef>
-          <a:fillRef idx="3">
-            <a:schemeClr val="accent1"/>
-          </a:fillRef>
-          <a:effectRef idx="2">
-            <a:schemeClr val="accent1"/>
-          </a:effectRef>
-          <a:fontRef idx="minor">
-            <a:schemeClr val="lt1"/>
-          </a:fontRef>
-        </p:style>
-        <p:txBody>
-          <a:bodyPr rtlCol="0" anchor="ctr"/>
-          <a:lstStyle/>
-          <a:p>
-            <a:pPr algn="ctr"/>
-          </a:p>
-        </p:txBody>
-      </p:sp>
-      <p:sp>
-        <p:nvSpPr>
-          <p:cNvPr id="10" name="Rectangle 9"/>
-          <p:cNvSpPr/>
-          <p:nvPr/>
-        </p:nvSpPr>
-        <p:spPr>
-          <a:xfrm>
-            <a:off x="448056" y="1271016"/>
-            <a:ext cx="64008" cy="64008"/>
-          </a:xfrm>
-          <a:prstGeom prst="rect">
-            <a:avLst/>
-          </a:prstGeom>
-          <a:solidFill>
-            <a:srgbClr val="FFFFFF"/>
-          </a:solidFill>
-          <a:ln>
-            <a:noFill/>
-          </a:ln>
-        </p:spPr>
-        <p:style>
-          <a:lnRef idx="1">
-            <a:schemeClr val="accent1"/>
-          </a:lnRef>
-          <a:fillRef idx="3">
-            <a:schemeClr val="accent1"/>
-          </a:fillRef>
-          <a:effectRef idx="2">
-            <a:schemeClr val="accent1"/>
-          </a:effectRef>
-          <a:fontRef idx="minor">
-            <a:schemeClr val="lt1"/>
-          </a:fontRef>
-        </p:style>
-        <p:txBody>
-          <a:bodyPr rtlCol="0" anchor="ctr"/>
-          <a:lstStyle/>
-          <a:p>
-            <a:pPr algn="ctr"/>
-          </a:p>
-        </p:txBody>
-      </p:sp>
-      <p:sp>
-        <p:nvSpPr>
-          <p:cNvPr id="11" name="Rectangle 10"/>
-          <p:cNvSpPr/>
-          <p:nvPr/>
-        </p:nvSpPr>
-        <p:spPr>
-          <a:xfrm>
-            <a:off x="539496" y="1271016"/>
-            <a:ext cx="64008" cy="64008"/>
-          </a:xfrm>
-          <a:prstGeom prst="rect">
-            <a:avLst/>
-          </a:prstGeom>
-          <a:solidFill>
-            <a:srgbClr val="FFFFFF"/>
-          </a:solidFill>
-          <a:ln>
-            <a:noFill/>
-          </a:ln>
-        </p:spPr>
-        <p:style>
-          <a:lnRef idx="1">
-            <a:schemeClr val="accent1"/>
-          </a:lnRef>
-          <a:fillRef idx="3">
-            <a:schemeClr val="accent1"/>
-          </a:fillRef>
-          <a:effectRef idx="2">
-            <a:schemeClr val="accent1"/>
-          </a:effectRef>
-          <a:fontRef idx="minor">
-            <a:schemeClr val="lt1"/>
-          </a:fontRef>
-        </p:style>
-        <p:txBody>
-          <a:bodyPr rtlCol="0" anchor="ctr"/>
-          <a:lstStyle/>
-          <a:p>
-            <a:pPr algn="ctr"/>
-          </a:p>
-        </p:txBody>
-      </p:sp>
-      <p:sp>
-        <p:nvSpPr>
-          <p:cNvPr id="12" name="Rectangle 11"/>
-          <p:cNvSpPr/>
-          <p:nvPr/>
-        </p:nvSpPr>
-        <p:spPr>
-          <a:xfrm>
-            <a:off x="365760" y="1481328"/>
-            <a:ext cx="2057400" cy="91440"/>
-          </a:xfrm>
-          <a:prstGeom prst="rect">
-            <a:avLst/>
-          </a:prstGeom>
-          <a:solidFill>
-            <a:srgbClr val="E8F4FD"/>
-          </a:solidFill>
-          <a:ln>
-            <a:noFill/>
-          </a:ln>
-        </p:spPr>
-        <p:style>
-          <a:lnRef idx="1">
-            <a:schemeClr val="accent1"/>
-          </a:lnRef>
-          <a:fillRef idx="3">
-            <a:schemeClr val="accent1"/>
-          </a:fillRef>
-          <a:effectRef idx="2">
-            <a:schemeClr val="accent1"/>
-          </a:effectRef>
-          <a:fontRef idx="minor">
-            <a:schemeClr val="lt1"/>
-          </a:fontRef>
-        </p:style>
-        <p:txBody>
-          <a:bodyPr rtlCol="0" anchor="ctr"/>
-          <a:lstStyle/>
-          <a:p>
-            <a:pPr algn="ctr"/>
-          </a:p>
-        </p:txBody>
-      </p:sp>
-      <p:sp>
-        <p:nvSpPr>
-          <p:cNvPr id="13" name="Rectangle 12"/>
-          <p:cNvSpPr/>
-          <p:nvPr/>
-        </p:nvSpPr>
-        <p:spPr>
-          <a:xfrm>
-            <a:off x="365760" y="1636776"/>
-            <a:ext cx="1691640" cy="91440"/>
-          </a:xfrm>
-          <a:prstGeom prst="rect">
-            <a:avLst/>
-          </a:prstGeom>
-          <a:solidFill>
-            <a:srgbClr val="E8F4FD"/>
-          </a:solidFill>
-          <a:ln>
-            <a:noFill/>
-          </a:ln>
-        </p:spPr>
-        <p:style>
-          <a:lnRef idx="1">
-            <a:schemeClr val="accent1"/>
-          </a:lnRef>
-          <a:fillRef idx="3">
-            <a:schemeClr val="accent1"/>
-          </a:fillRef>
-          <a:effectRef idx="2">
-            <a:schemeClr val="accent1"/>
-          </a:effectRef>
-          <a:fontRef idx="minor">
-            <a:schemeClr val="lt1"/>
-          </a:fontRef>
-        </p:style>
-        <p:txBody>
-          <a:bodyPr rtlCol="0" anchor="ctr"/>
-          <a:lstStyle/>
-          <a:p>
-            <a:pPr algn="ctr"/>
-          </a:p>
-        </p:txBody>
-      </p:sp>
-      <p:sp>
-        <p:nvSpPr>
-          <p:cNvPr id="14" name="Rectangle 13"/>
-          <p:cNvSpPr/>
-          <p:nvPr/>
-        </p:nvSpPr>
-        <p:spPr>
-          <a:xfrm>
-            <a:off x="365760" y="1792224"/>
-            <a:ext cx="2057400" cy="91440"/>
-          </a:xfrm>
-          <a:prstGeom prst="rect">
-            <a:avLst/>
-          </a:prstGeom>
-          <a:solidFill>
-            <a:srgbClr val="CCCCCC"/>
-          </a:solidFill>
-          <a:ln>
-            <a:noFill/>
-          </a:ln>
-        </p:spPr>
-        <p:style>
-          <a:lnRef idx="1">
-            <a:schemeClr val="accent1"/>
-          </a:lnRef>
-          <a:fillRef idx="3">
-            <a:schemeClr val="accent1"/>
-          </a:fillRef>
-          <a:effectRef idx="2">
-            <a:schemeClr val="accent1"/>
-          </a:effectRef>
-          <a:fontRef idx="minor">
-            <a:schemeClr val="lt1"/>
-          </a:fontRef>
-        </p:style>
-        <p:txBody>
-          <a:bodyPr rtlCol="0" anchor="ctr"/>
-          <a:lstStyle/>
-          <a:p>
-            <a:pPr algn="ctr"/>
-          </a:p>
-        </p:txBody>
-      </p:sp>
-      <p:sp>
-        <p:nvSpPr>
-          <p:cNvPr id="15" name="Rectangle 14"/>
-          <p:cNvSpPr/>
-          <p:nvPr/>
-        </p:nvSpPr>
-        <p:spPr>
-          <a:xfrm>
-            <a:off x="365760" y="1947672"/>
-            <a:ext cx="1691640" cy="91440"/>
-          </a:xfrm>
-          <a:prstGeom prst="rect">
-            <a:avLst/>
-          </a:prstGeom>
-          <a:solidFill>
-            <a:srgbClr val="CCCCCC"/>
-          </a:solidFill>
-          <a:ln>
-            <a:noFill/>
-          </a:ln>
-        </p:spPr>
-        <p:style>
-          <a:lnRef idx="1">
-            <a:schemeClr val="accent1"/>
-          </a:lnRef>
-          <a:fillRef idx="3">
-            <a:schemeClr val="accent1"/>
-          </a:fillRef>
-          <a:effectRef idx="2">
-            <a:schemeClr val="accent1"/>
-          </a:effectRef>
-          <a:fontRef idx="minor">
-            <a:schemeClr val="lt1"/>
-          </a:fontRef>
-        </p:style>
-        <p:txBody>
-          <a:bodyPr rtlCol="0" anchor="ctr"/>
-          <a:lstStyle/>
-          <a:p>
-            <a:pPr algn="ctr"/>
-          </a:p>
-        </p:txBody>
-      </p:sp>
-      <p:sp>
-        <p:nvSpPr>
-          <p:cNvPr id="16" name="TextBox 15"/>
-          <p:cNvSpPr txBox="1"/>
-          <p:nvPr/>
-        </p:nvSpPr>
-        <p:spPr>
-          <a:xfrm>
-            <a:off x="274320" y="2194560"/>
-            <a:ext cx="2240280" cy="292608"/>
-          </a:xfrm>
-          <a:prstGeom prst="rect">
-            <a:avLst/>
-          </a:prstGeom>
-          <a:noFill/>
-        </p:spPr>
-        <p:txBody>
-          <a:bodyPr wrap="square">
-            <a:spAutoFit/>
-          </a:bodyPr>
-          <a:lstStyle/>
-          <a:p>
-            <a:pPr algn="l"/>
-            <a:r>
-              <a:rPr sz="1000" b="1" i="0">
-                <a:solidFill>
-                  <a:srgbClr val="0A6EBD"/>
-                </a:solidFill>
-                <a:latin typeface="Calibri"/>
-              </a:rPr>
-              <a:t>1. Home — Process New Claim</a:t>
-            </a:r>
-          </a:p>
-        </p:txBody>
-      </p:sp>
-      <p:sp>
-        <p:nvSpPr>
-          <p:cNvPr id="17" name="TextBox 16"/>
-          <p:cNvSpPr txBox="1"/>
-          <p:nvPr/>
-        </p:nvSpPr>
-        <p:spPr>
-          <a:xfrm>
-            <a:off x="274320" y="2514600"/>
-            <a:ext cx="2240280" cy="960120"/>
-          </a:xfrm>
-          <a:prstGeom prst="rect">
-            <a:avLst/>
-          </a:prstGeom>
-          <a:noFill/>
-        </p:spPr>
-        <p:txBody>
-          <a:bodyPr wrap="square">
-            <a:spAutoFit/>
-          </a:bodyPr>
-          <a:lstStyle/>
-          <a:p>
-            <a:pPr>
-              <a:spcBef>
-                <a:spcPts val="100"/>
-              </a:spcBef>
-            </a:pPr>
-            <a:r>
-              <a:rPr sz="900">
-                <a:solidFill>
-                  <a:srgbClr val="1A1A2E"/>
-                </a:solidFill>
-                <a:latin typeface="Calibri"/>
-              </a:rPr>
-              <a:t>• File upload drag-and-drop zone</a:t>
-            </a:r>
-          </a:p>
-          <a:p>
-            <a:pPr>
-              <a:spcBef>
-                <a:spcPts val="100"/>
-              </a:spcBef>
-            </a:pPr>
-            <a:r>
-              <a:rPr sz="900">
-                <a:solidFill>
-                  <a:srgbClr val="1A1A2E"/>
-                </a:solidFill>
-                <a:latin typeface="Calibri"/>
-              </a:rPr>
-              <a:t>• OR select from 10 pre-built sample claims</a:t>
-            </a:r>
-          </a:p>
-          <a:p>
-            <a:pPr>
-              <a:spcBef>
-                <a:spcPts val="100"/>
-              </a:spcBef>
-            </a:pPr>
-            <a:r>
-              <a:rPr sz="900">
-                <a:solidFill>
-                  <a:srgbClr val="1A1A2E"/>
-                </a:solidFill>
-                <a:latin typeface="Calibri"/>
-              </a:rPr>
-              <a:t>• Sidebar: OpenAI ✅  ChromaDB ✅  S3 ✅</a:t>
-            </a:r>
-          </a:p>
-          <a:p>
-            <a:pPr>
-              <a:spcBef>
-                <a:spcPts val="100"/>
-              </a:spcBef>
-            </a:pPr>
-            <a:r>
-              <a:rPr sz="900">
-                <a:solidFill>
-                  <a:srgbClr val="1A1A2E"/>
-                </a:solidFill>
-                <a:latin typeface="Calibri"/>
-              </a:rPr>
-              <a:t>• Quick Actions: Generate Data / Build RAG Index</a:t>
-            </a:r>
-          </a:p>
-        </p:txBody>
-      </p:sp>
-      <p:sp>
-        <p:nvSpPr>
           <p:cNvPr id="18" name="Rectangle 17"/>
           <p:cNvSpPr/>
           <p:nvPr/>
@@ -20452,472 +19986,6 @@
       </p:sp>
       <p:sp>
         <p:nvSpPr>
-          <p:cNvPr id="19" name="Rectangle 18"/>
-          <p:cNvSpPr/>
-          <p:nvPr/>
-        </p:nvSpPr>
-        <p:spPr>
-          <a:xfrm>
-            <a:off x="2679192" y="1243584"/>
-            <a:ext cx="2130552" cy="164592"/>
-          </a:xfrm>
-          <a:prstGeom prst="rect">
-            <a:avLst/>
-          </a:prstGeom>
-          <a:solidFill>
-            <a:srgbClr val="0A6EBD"/>
-          </a:solidFill>
-          <a:ln>
-            <a:noFill/>
-          </a:ln>
-        </p:spPr>
-        <p:style>
-          <a:lnRef idx="1">
-            <a:schemeClr val="accent1"/>
-          </a:lnRef>
-          <a:fillRef idx="3">
-            <a:schemeClr val="accent1"/>
-          </a:fillRef>
-          <a:effectRef idx="2">
-            <a:schemeClr val="accent1"/>
-          </a:effectRef>
-          <a:fontRef idx="minor">
-            <a:schemeClr val="lt1"/>
-          </a:fontRef>
-        </p:style>
-        <p:txBody>
-          <a:bodyPr rtlCol="0" anchor="ctr"/>
-          <a:lstStyle/>
-          <a:p>
-            <a:pPr algn="ctr"/>
-          </a:p>
-        </p:txBody>
-      </p:sp>
-      <p:sp>
-        <p:nvSpPr>
-          <p:cNvPr id="20" name="Rectangle 19"/>
-          <p:cNvSpPr/>
-          <p:nvPr/>
-        </p:nvSpPr>
-        <p:spPr>
-          <a:xfrm>
-            <a:off x="2706624" y="1271016"/>
-            <a:ext cx="64008" cy="64008"/>
-          </a:xfrm>
-          <a:prstGeom prst="rect">
-            <a:avLst/>
-          </a:prstGeom>
-          <a:solidFill>
-            <a:srgbClr val="FFFFFF"/>
-          </a:solidFill>
-          <a:ln>
-            <a:noFill/>
-          </a:ln>
-        </p:spPr>
-        <p:style>
-          <a:lnRef idx="1">
-            <a:schemeClr val="accent1"/>
-          </a:lnRef>
-          <a:fillRef idx="3">
-            <a:schemeClr val="accent1"/>
-          </a:fillRef>
-          <a:effectRef idx="2">
-            <a:schemeClr val="accent1"/>
-          </a:effectRef>
-          <a:fontRef idx="minor">
-            <a:schemeClr val="lt1"/>
-          </a:fontRef>
-        </p:style>
-        <p:txBody>
-          <a:bodyPr rtlCol="0" anchor="ctr"/>
-          <a:lstStyle/>
-          <a:p>
-            <a:pPr algn="ctr"/>
-          </a:p>
-        </p:txBody>
-      </p:sp>
-      <p:sp>
-        <p:nvSpPr>
-          <p:cNvPr id="21" name="Rectangle 20"/>
-          <p:cNvSpPr/>
-          <p:nvPr/>
-        </p:nvSpPr>
-        <p:spPr>
-          <a:xfrm>
-            <a:off x="2798064" y="1271016"/>
-            <a:ext cx="64008" cy="64008"/>
-          </a:xfrm>
-          <a:prstGeom prst="rect">
-            <a:avLst/>
-          </a:prstGeom>
-          <a:solidFill>
-            <a:srgbClr val="FFFFFF"/>
-          </a:solidFill>
-          <a:ln>
-            <a:noFill/>
-          </a:ln>
-        </p:spPr>
-        <p:style>
-          <a:lnRef idx="1">
-            <a:schemeClr val="accent1"/>
-          </a:lnRef>
-          <a:fillRef idx="3">
-            <a:schemeClr val="accent1"/>
-          </a:fillRef>
-          <a:effectRef idx="2">
-            <a:schemeClr val="accent1"/>
-          </a:effectRef>
-          <a:fontRef idx="minor">
-            <a:schemeClr val="lt1"/>
-          </a:fontRef>
-        </p:style>
-        <p:txBody>
-          <a:bodyPr rtlCol="0" anchor="ctr"/>
-          <a:lstStyle/>
-          <a:p>
-            <a:pPr algn="ctr"/>
-          </a:p>
-        </p:txBody>
-      </p:sp>
-      <p:sp>
-        <p:nvSpPr>
-          <p:cNvPr id="22" name="Rectangle 21"/>
-          <p:cNvSpPr/>
-          <p:nvPr/>
-        </p:nvSpPr>
-        <p:spPr>
-          <a:xfrm>
-            <a:off x="2889504" y="1271016"/>
-            <a:ext cx="64008" cy="64008"/>
-          </a:xfrm>
-          <a:prstGeom prst="rect">
-            <a:avLst/>
-          </a:prstGeom>
-          <a:solidFill>
-            <a:srgbClr val="FFFFFF"/>
-          </a:solidFill>
-          <a:ln>
-            <a:noFill/>
-          </a:ln>
-        </p:spPr>
-        <p:style>
-          <a:lnRef idx="1">
-            <a:schemeClr val="accent1"/>
-          </a:lnRef>
-          <a:fillRef idx="3">
-            <a:schemeClr val="accent1"/>
-          </a:fillRef>
-          <a:effectRef idx="2">
-            <a:schemeClr val="accent1"/>
-          </a:effectRef>
-          <a:fontRef idx="minor">
-            <a:schemeClr val="lt1"/>
-          </a:fontRef>
-        </p:style>
-        <p:txBody>
-          <a:bodyPr rtlCol="0" anchor="ctr"/>
-          <a:lstStyle/>
-          <a:p>
-            <a:pPr algn="ctr"/>
-          </a:p>
-        </p:txBody>
-      </p:sp>
-      <p:sp>
-        <p:nvSpPr>
-          <p:cNvPr id="23" name="Rectangle 22"/>
-          <p:cNvSpPr/>
-          <p:nvPr/>
-        </p:nvSpPr>
-        <p:spPr>
-          <a:xfrm>
-            <a:off x="2715768" y="1481328"/>
-            <a:ext cx="2057400" cy="91440"/>
-          </a:xfrm>
-          <a:prstGeom prst="rect">
-            <a:avLst/>
-          </a:prstGeom>
-          <a:solidFill>
-            <a:srgbClr val="E8F4FD"/>
-          </a:solidFill>
-          <a:ln>
-            <a:noFill/>
-          </a:ln>
-        </p:spPr>
-        <p:style>
-          <a:lnRef idx="1">
-            <a:schemeClr val="accent1"/>
-          </a:lnRef>
-          <a:fillRef idx="3">
-            <a:schemeClr val="accent1"/>
-          </a:fillRef>
-          <a:effectRef idx="2">
-            <a:schemeClr val="accent1"/>
-          </a:effectRef>
-          <a:fontRef idx="minor">
-            <a:schemeClr val="lt1"/>
-          </a:fontRef>
-        </p:style>
-        <p:txBody>
-          <a:bodyPr rtlCol="0" anchor="ctr"/>
-          <a:lstStyle/>
-          <a:p>
-            <a:pPr algn="ctr"/>
-          </a:p>
-        </p:txBody>
-      </p:sp>
-      <p:sp>
-        <p:nvSpPr>
-          <p:cNvPr id="24" name="Rectangle 23"/>
-          <p:cNvSpPr/>
-          <p:nvPr/>
-        </p:nvSpPr>
-        <p:spPr>
-          <a:xfrm>
-            <a:off x="2715768" y="1636776"/>
-            <a:ext cx="1691640" cy="91440"/>
-          </a:xfrm>
-          <a:prstGeom prst="rect">
-            <a:avLst/>
-          </a:prstGeom>
-          <a:solidFill>
-            <a:srgbClr val="E8F4FD"/>
-          </a:solidFill>
-          <a:ln>
-            <a:noFill/>
-          </a:ln>
-        </p:spPr>
-        <p:style>
-          <a:lnRef idx="1">
-            <a:schemeClr val="accent1"/>
-          </a:lnRef>
-          <a:fillRef idx="3">
-            <a:schemeClr val="accent1"/>
-          </a:fillRef>
-          <a:effectRef idx="2">
-            <a:schemeClr val="accent1"/>
-          </a:effectRef>
-          <a:fontRef idx="minor">
-            <a:schemeClr val="lt1"/>
-          </a:fontRef>
-        </p:style>
-        <p:txBody>
-          <a:bodyPr rtlCol="0" anchor="ctr"/>
-          <a:lstStyle/>
-          <a:p>
-            <a:pPr algn="ctr"/>
-          </a:p>
-        </p:txBody>
-      </p:sp>
-      <p:sp>
-        <p:nvSpPr>
-          <p:cNvPr id="25" name="Rectangle 24"/>
-          <p:cNvSpPr/>
-          <p:nvPr/>
-        </p:nvSpPr>
-        <p:spPr>
-          <a:xfrm>
-            <a:off x="2715768" y="1792224"/>
-            <a:ext cx="2057400" cy="91440"/>
-          </a:xfrm>
-          <a:prstGeom prst="rect">
-            <a:avLst/>
-          </a:prstGeom>
-          <a:solidFill>
-            <a:srgbClr val="CCCCCC"/>
-          </a:solidFill>
-          <a:ln>
-            <a:noFill/>
-          </a:ln>
-        </p:spPr>
-        <p:style>
-          <a:lnRef idx="1">
-            <a:schemeClr val="accent1"/>
-          </a:lnRef>
-          <a:fillRef idx="3">
-            <a:schemeClr val="accent1"/>
-          </a:fillRef>
-          <a:effectRef idx="2">
-            <a:schemeClr val="accent1"/>
-          </a:effectRef>
-          <a:fontRef idx="minor">
-            <a:schemeClr val="lt1"/>
-          </a:fontRef>
-        </p:style>
-        <p:txBody>
-          <a:bodyPr rtlCol="0" anchor="ctr"/>
-          <a:lstStyle/>
-          <a:p>
-            <a:pPr algn="ctr"/>
-          </a:p>
-        </p:txBody>
-      </p:sp>
-      <p:sp>
-        <p:nvSpPr>
-          <p:cNvPr id="26" name="Rectangle 25"/>
-          <p:cNvSpPr/>
-          <p:nvPr/>
-        </p:nvSpPr>
-        <p:spPr>
-          <a:xfrm>
-            <a:off x="2715768" y="1947672"/>
-            <a:ext cx="1691640" cy="91440"/>
-          </a:xfrm>
-          <a:prstGeom prst="rect">
-            <a:avLst/>
-          </a:prstGeom>
-          <a:solidFill>
-            <a:srgbClr val="CCCCCC"/>
-          </a:solidFill>
-          <a:ln>
-            <a:noFill/>
-          </a:ln>
-        </p:spPr>
-        <p:style>
-          <a:lnRef idx="1">
-            <a:schemeClr val="accent1"/>
-          </a:lnRef>
-          <a:fillRef idx="3">
-            <a:schemeClr val="accent1"/>
-          </a:fillRef>
-          <a:effectRef idx="2">
-            <a:schemeClr val="accent1"/>
-          </a:effectRef>
-          <a:fontRef idx="minor">
-            <a:schemeClr val="lt1"/>
-          </a:fontRef>
-        </p:style>
-        <p:txBody>
-          <a:bodyPr rtlCol="0" anchor="ctr"/>
-          <a:lstStyle/>
-          <a:p>
-            <a:pPr algn="ctr"/>
-          </a:p>
-        </p:txBody>
-      </p:sp>
-      <p:sp>
-        <p:nvSpPr>
-          <p:cNvPr id="27" name="TextBox 26"/>
-          <p:cNvSpPr txBox="1"/>
-          <p:nvPr/>
-        </p:nvSpPr>
-        <p:spPr>
-          <a:xfrm>
-            <a:off x="2624328" y="2194560"/>
-            <a:ext cx="2240280" cy="292608"/>
-          </a:xfrm>
-          <a:prstGeom prst="rect">
-            <a:avLst/>
-          </a:prstGeom>
-          <a:noFill/>
-        </p:spPr>
-        <p:txBody>
-          <a:bodyPr wrap="square">
-            <a:spAutoFit/>
-          </a:bodyPr>
-          <a:lstStyle/>
-          <a:p>
-            <a:pPr algn="l"/>
-            <a:r>
-              <a:rPr sz="1000" b="1" i="0">
-                <a:solidFill>
-                  <a:srgbClr val="0A6EBD"/>
-                </a:solidFill>
-                <a:latin typeface="Calibri"/>
-              </a:rPr>
-              <a:t>2. AI Processing Pipeline</a:t>
-            </a:r>
-          </a:p>
-        </p:txBody>
-      </p:sp>
-      <p:sp>
-        <p:nvSpPr>
-          <p:cNvPr id="28" name="TextBox 27"/>
-          <p:cNvSpPr txBox="1"/>
-          <p:nvPr/>
-        </p:nvSpPr>
-        <p:spPr>
-          <a:xfrm>
-            <a:off x="2624328" y="2514600"/>
-            <a:ext cx="2240280" cy="960120"/>
-          </a:xfrm>
-          <a:prstGeom prst="rect">
-            <a:avLst/>
-          </a:prstGeom>
-          <a:noFill/>
-        </p:spPr>
-        <p:txBody>
-          <a:bodyPr wrap="square">
-            <a:spAutoFit/>
-          </a:bodyPr>
-          <a:lstStyle/>
-          <a:p>
-            <a:pPr>
-              <a:spcBef>
-                <a:spcPts val="100"/>
-              </a:spcBef>
-            </a:pPr>
-            <a:r>
-              <a:rPr sz="900">
-                <a:solidFill>
-                  <a:srgbClr val="1A1A2E"/>
-                </a:solidFill>
-                <a:latin typeface="Calibri"/>
-              </a:rPr>
-              <a:t>• 4-step stepper: OCR → Validate → Recommend → Human</a:t>
-            </a:r>
-          </a:p>
-          <a:p>
-            <a:pPr>
-              <a:spcBef>
-                <a:spcPts val="100"/>
-              </a:spcBef>
-            </a:pPr>
-            <a:r>
-              <a:rPr sz="900">
-                <a:solidFill>
-                  <a:srgbClr val="1A1A2E"/>
-                </a:solidFill>
-                <a:latin typeface="Calibri"/>
-              </a:rPr>
-              <a:t>• Extracted fields card with ✅ / ⚠️ per field</a:t>
-            </a:r>
-          </a:p>
-          <a:p>
-            <a:pPr>
-              <a:spcBef>
-                <a:spcPts val="100"/>
-              </a:spcBef>
-            </a:pPr>
-            <a:r>
-              <a:rPr sz="900">
-                <a:solidFill>
-                  <a:srgbClr val="1A1A2E"/>
-                </a:solidFill>
-                <a:latin typeface="Calibri"/>
-              </a:rPr>
-              <a:t>• Validation severity badge (LOW / MEDIUM / HIGH)</a:t>
-            </a:r>
-          </a:p>
-          <a:p>
-            <a:pPr>
-              <a:spcBef>
-                <a:spcPts val="100"/>
-              </a:spcBef>
-            </a:pPr>
-            <a:r>
-              <a:rPr sz="900">
-                <a:solidFill>
-                  <a:srgbClr val="1A1A2E"/>
-                </a:solidFill>
-                <a:latin typeface="Calibri"/>
-              </a:rPr>
-              <a:t>• AI recommendation with confidence + citations</a:t>
-            </a:r>
-          </a:p>
-        </p:txBody>
-      </p:sp>
-      <p:sp>
-        <p:nvSpPr>
           <p:cNvPr id="29" name="Rectangle 28"/>
           <p:cNvSpPr/>
           <p:nvPr/>
@@ -20959,1486 +20027,322 @@
           </a:p>
         </p:txBody>
       </p:sp>
-      <p:sp>
-        <p:nvSpPr>
-          <p:cNvPr id="30" name="Rectangle 29"/>
-          <p:cNvSpPr/>
-          <p:nvPr/>
-        </p:nvSpPr>
-        <p:spPr>
-          <a:xfrm>
-            <a:off x="5029200" y="1243584"/>
-            <a:ext cx="2130552" cy="164592"/>
-          </a:xfrm>
-          <a:prstGeom prst="rect">
-            <a:avLst/>
-          </a:prstGeom>
-          <a:solidFill>
-            <a:srgbClr val="0A6EBD"/>
-          </a:solidFill>
-          <a:ln>
-            <a:noFill/>
+      <p:pic>
+        <p:nvPicPr>
+          <p:cNvPr id="30" name="Picture 29" descr="01_home.png"/>
+          <p:cNvPicPr>
+            <a:picLocks noChangeAspect="1"/>
+          </p:cNvPicPr>
+          <p:nvPr/>
+        </p:nvPicPr>
+        <p:blipFill>
+          <a:blip r:embed="rId2"/>
+          <a:stretch>
+            <a:fillRect/>
+          </a:stretch>
+        </p:blipFill>
+        <p:spPr>
+          <a:xfrm>
+            <a:off x="274320" y="1207008"/>
+            <a:ext cx="3657600" cy="2286000"/>
+          </a:xfrm>
+          <a:prstGeom prst="rect">
+            <a:avLst/>
+          </a:prstGeom>
+          <a:ln w="12700">
+            <a:solidFill>
+              <a:srgbClr val="0A6EBD"/>
+            </a:solidFill>
           </a:ln>
         </p:spPr>
-        <p:style>
-          <a:lnRef idx="1">
-            <a:schemeClr val="accent1"/>
-          </a:lnRef>
-          <a:fillRef idx="3">
-            <a:schemeClr val="accent1"/>
-          </a:fillRef>
-          <a:effectRef idx="2">
-            <a:schemeClr val="accent1"/>
-          </a:effectRef>
-          <a:fontRef idx="minor">
-            <a:schemeClr val="lt1"/>
-          </a:fontRef>
-        </p:style>
-        <p:txBody>
-          <a:bodyPr rtlCol="0" anchor="ctr"/>
-          <a:lstStyle/>
-          <a:p>
-            <a:pPr algn="ctr"/>
-          </a:p>
-        </p:txBody>
-      </p:sp>
-      <p:sp>
-        <p:nvSpPr>
-          <p:cNvPr id="31" name="Rectangle 30"/>
-          <p:cNvSpPr/>
-          <p:nvPr/>
-        </p:nvSpPr>
-        <p:spPr>
-          <a:xfrm>
-            <a:off x="5056632" y="1271016"/>
-            <a:ext cx="64008" cy="64008"/>
-          </a:xfrm>
-          <a:prstGeom prst="rect">
-            <a:avLst/>
-          </a:prstGeom>
-          <a:solidFill>
-            <a:srgbClr val="FFFFFF"/>
-          </a:solidFill>
-          <a:ln>
-            <a:noFill/>
+      </p:pic>
+      <p:sp>
+        <p:nvSpPr>
+          <p:cNvPr id="31" name="TextBox 30"/>
+          <p:cNvSpPr txBox="1"/>
+          <p:nvPr/>
+        </p:nvSpPr>
+        <p:spPr>
+          <a:xfrm>
+            <a:off x="274320" y="3529584"/>
+            <a:ext cx="3657600" cy="274320"/>
+          </a:xfrm>
+          <a:prstGeom prst="rect">
+            <a:avLst/>
+          </a:prstGeom>
+          <a:noFill/>
+        </p:spPr>
+        <p:txBody>
+          <a:bodyPr wrap="square">
+            <a:spAutoFit/>
+          </a:bodyPr>
+          <a:lstStyle/>
+          <a:p>
+            <a:pPr algn="ctr"/>
+            <a:r>
+              <a:rPr sz="1000" b="1">
+                <a:solidFill>
+                  <a:srgbClr val="0A6EBD"/>
+                </a:solidFill>
+                <a:latin typeface="Calibri"/>
+              </a:rPr>
+              <a:t>1. Home — Upload &amp; System Status</a:t>
+            </a:r>
+          </a:p>
+        </p:txBody>
+      </p:sp>
+      <p:pic>
+        <p:nvPicPr>
+          <p:cNvPr id="32" name="Picture 31" descr="03_pipeline_complete.png"/>
+          <p:cNvPicPr>
+            <a:picLocks noChangeAspect="1"/>
+          </p:cNvPicPr>
+          <p:nvPr/>
+        </p:nvPicPr>
+        <p:blipFill>
+          <a:blip r:embed="rId3"/>
+          <a:stretch>
+            <a:fillRect/>
+          </a:stretch>
+        </p:blipFill>
+        <p:spPr>
+          <a:xfrm>
+            <a:off x="4073652" y="1207008"/>
+            <a:ext cx="3657600" cy="2286000"/>
+          </a:xfrm>
+          <a:prstGeom prst="rect">
+            <a:avLst/>
+          </a:prstGeom>
+          <a:ln w="12700">
+            <a:solidFill>
+              <a:srgbClr val="0A6EBD"/>
+            </a:solidFill>
           </a:ln>
         </p:spPr>
-        <p:style>
-          <a:lnRef idx="1">
-            <a:schemeClr val="accent1"/>
-          </a:lnRef>
-          <a:fillRef idx="3">
-            <a:schemeClr val="accent1"/>
-          </a:fillRef>
-          <a:effectRef idx="2">
-            <a:schemeClr val="accent1"/>
-          </a:effectRef>
-          <a:fontRef idx="minor">
-            <a:schemeClr val="lt1"/>
-          </a:fontRef>
-        </p:style>
-        <p:txBody>
-          <a:bodyPr rtlCol="0" anchor="ctr"/>
-          <a:lstStyle/>
-          <a:p>
-            <a:pPr algn="ctr"/>
-          </a:p>
-        </p:txBody>
-      </p:sp>
-      <p:sp>
-        <p:nvSpPr>
-          <p:cNvPr id="32" name="Rectangle 31"/>
-          <p:cNvSpPr/>
-          <p:nvPr/>
-        </p:nvSpPr>
-        <p:spPr>
-          <a:xfrm>
-            <a:off x="5148072" y="1271016"/>
-            <a:ext cx="64008" cy="64008"/>
-          </a:xfrm>
-          <a:prstGeom prst="rect">
-            <a:avLst/>
-          </a:prstGeom>
-          <a:solidFill>
-            <a:srgbClr val="FFFFFF"/>
-          </a:solidFill>
-          <a:ln>
-            <a:noFill/>
+      </p:pic>
+      <p:sp>
+        <p:nvSpPr>
+          <p:cNvPr id="33" name="TextBox 32"/>
+          <p:cNvSpPr txBox="1"/>
+          <p:nvPr/>
+        </p:nvSpPr>
+        <p:spPr>
+          <a:xfrm>
+            <a:off x="4073652" y="3529584"/>
+            <a:ext cx="3657600" cy="274320"/>
+          </a:xfrm>
+          <a:prstGeom prst="rect">
+            <a:avLst/>
+          </a:prstGeom>
+          <a:noFill/>
+        </p:spPr>
+        <p:txBody>
+          <a:bodyPr wrap="square">
+            <a:spAutoFit/>
+          </a:bodyPr>
+          <a:lstStyle/>
+          <a:p>
+            <a:pPr algn="ctr"/>
+            <a:r>
+              <a:rPr sz="1000" b="1">
+                <a:solidFill>
+                  <a:srgbClr val="0A6EBD"/>
+                </a:solidFill>
+                <a:latin typeface="Calibri"/>
+              </a:rPr>
+              <a:t>2. AI Pipeline — OCR Extraction Results</a:t>
+            </a:r>
+          </a:p>
+        </p:txBody>
+      </p:sp>
+      <p:pic>
+        <p:nvPicPr>
+          <p:cNvPr id="34" name="Picture 33" descr="03_pipeline_complete.png"/>
+          <p:cNvPicPr>
+            <a:picLocks noChangeAspect="1"/>
+          </p:cNvPicPr>
+          <p:nvPr/>
+        </p:nvPicPr>
+        <p:blipFill>
+          <a:blip r:embed="rId3"/>
+          <a:stretch>
+            <a:fillRect/>
+          </a:stretch>
+        </p:blipFill>
+        <p:spPr>
+          <a:xfrm>
+            <a:off x="7872983" y="1207008"/>
+            <a:ext cx="3657600" cy="2286000"/>
+          </a:xfrm>
+          <a:prstGeom prst="rect">
+            <a:avLst/>
+          </a:prstGeom>
+          <a:ln w="12700">
+            <a:solidFill>
+              <a:srgbClr val="0A6EBD"/>
+            </a:solidFill>
           </a:ln>
         </p:spPr>
-        <p:style>
-          <a:lnRef idx="1">
-            <a:schemeClr val="accent1"/>
-          </a:lnRef>
-          <a:fillRef idx="3">
-            <a:schemeClr val="accent1"/>
-          </a:fillRef>
-          <a:effectRef idx="2">
-            <a:schemeClr val="accent1"/>
-          </a:effectRef>
-          <a:fontRef idx="minor">
-            <a:schemeClr val="lt1"/>
-          </a:fontRef>
-        </p:style>
-        <p:txBody>
-          <a:bodyPr rtlCol="0" anchor="ctr"/>
-          <a:lstStyle/>
-          <a:p>
-            <a:pPr algn="ctr"/>
-          </a:p>
-        </p:txBody>
-      </p:sp>
-      <p:sp>
-        <p:nvSpPr>
-          <p:cNvPr id="33" name="Rectangle 32"/>
-          <p:cNvSpPr/>
-          <p:nvPr/>
-        </p:nvSpPr>
-        <p:spPr>
-          <a:xfrm>
-            <a:off x="5239512" y="1271016"/>
-            <a:ext cx="64008" cy="64008"/>
-          </a:xfrm>
-          <a:prstGeom prst="rect">
-            <a:avLst/>
-          </a:prstGeom>
-          <a:solidFill>
-            <a:srgbClr val="FFFFFF"/>
-          </a:solidFill>
-          <a:ln>
-            <a:noFill/>
+      </p:pic>
+      <p:sp>
+        <p:nvSpPr>
+          <p:cNvPr id="35" name="TextBox 34"/>
+          <p:cNvSpPr txBox="1"/>
+          <p:nvPr/>
+        </p:nvSpPr>
+        <p:spPr>
+          <a:xfrm>
+            <a:off x="7872983" y="3529584"/>
+            <a:ext cx="3657600" cy="274320"/>
+          </a:xfrm>
+          <a:prstGeom prst="rect">
+            <a:avLst/>
+          </a:prstGeom>
+          <a:noFill/>
+        </p:spPr>
+        <p:txBody>
+          <a:bodyPr wrap="square">
+            <a:spAutoFit/>
+          </a:bodyPr>
+          <a:lstStyle/>
+          <a:p>
+            <a:pPr algn="ctr"/>
+            <a:r>
+              <a:rPr sz="1000" b="1">
+                <a:solidFill>
+                  <a:srgbClr val="0A6EBD"/>
+                </a:solidFill>
+                <a:latin typeface="Calibri"/>
+              </a:rPr>
+              <a:t>3. AI Recommendation &amp; Policy Citations</a:t>
+            </a:r>
+          </a:p>
+        </p:txBody>
+      </p:sp>
+      <p:pic>
+        <p:nvPicPr>
+          <p:cNvPr id="36" name="Picture 35" descr="08_claims_history.png"/>
+          <p:cNvPicPr>
+            <a:picLocks noChangeAspect="1"/>
+          </p:cNvPicPr>
+          <p:nvPr/>
+        </p:nvPicPr>
+        <p:blipFill>
+          <a:blip r:embed="rId4"/>
+          <a:stretch>
+            <a:fillRect/>
+          </a:stretch>
+        </p:blipFill>
+        <p:spPr>
+          <a:xfrm>
+            <a:off x="2366010" y="3931920"/>
+            <a:ext cx="3657600" cy="2286000"/>
+          </a:xfrm>
+          <a:prstGeom prst="rect">
+            <a:avLst/>
+          </a:prstGeom>
+          <a:ln w="12700">
+            <a:solidFill>
+              <a:srgbClr val="0A6EBD"/>
+            </a:solidFill>
           </a:ln>
         </p:spPr>
-        <p:style>
-          <a:lnRef idx="1">
-            <a:schemeClr val="accent1"/>
-          </a:lnRef>
-          <a:fillRef idx="3">
-            <a:schemeClr val="accent1"/>
-          </a:fillRef>
-          <a:effectRef idx="2">
-            <a:schemeClr val="accent1"/>
-          </a:effectRef>
-          <a:fontRef idx="minor">
-            <a:schemeClr val="lt1"/>
-          </a:fontRef>
-        </p:style>
-        <p:txBody>
-          <a:bodyPr rtlCol="0" anchor="ctr"/>
-          <a:lstStyle/>
-          <a:p>
-            <a:pPr algn="ctr"/>
-          </a:p>
-        </p:txBody>
-      </p:sp>
-      <p:sp>
-        <p:nvSpPr>
-          <p:cNvPr id="34" name="Rectangle 33"/>
-          <p:cNvSpPr/>
-          <p:nvPr/>
-        </p:nvSpPr>
-        <p:spPr>
-          <a:xfrm>
-            <a:off x="5065776" y="1481328"/>
-            <a:ext cx="2057400" cy="91440"/>
-          </a:xfrm>
-          <a:prstGeom prst="rect">
-            <a:avLst/>
-          </a:prstGeom>
-          <a:solidFill>
-            <a:srgbClr val="E8F4FD"/>
-          </a:solidFill>
-          <a:ln>
-            <a:noFill/>
+      </p:pic>
+      <p:sp>
+        <p:nvSpPr>
+          <p:cNvPr id="37" name="TextBox 36"/>
+          <p:cNvSpPr txBox="1"/>
+          <p:nvPr/>
+        </p:nvSpPr>
+        <p:spPr>
+          <a:xfrm>
+            <a:off x="2366010" y="6254496"/>
+            <a:ext cx="3657600" cy="274320"/>
+          </a:xfrm>
+          <a:prstGeom prst="rect">
+            <a:avLst/>
+          </a:prstGeom>
+          <a:noFill/>
+        </p:spPr>
+        <p:txBody>
+          <a:bodyPr wrap="square">
+            <a:spAutoFit/>
+          </a:bodyPr>
+          <a:lstStyle/>
+          <a:p>
+            <a:pPr algn="ctr"/>
+            <a:r>
+              <a:rPr sz="1000" b="1">
+                <a:solidFill>
+                  <a:srgbClr val="0A6EBD"/>
+                </a:solidFill>
+                <a:latin typeface="Calibri"/>
+              </a:rPr>
+              <a:t>4. Claims History Dashboard</a:t>
+            </a:r>
+          </a:p>
+        </p:txBody>
+      </p:sp>
+      <p:pic>
+        <p:nvPicPr>
+          <p:cNvPr id="38" name="Picture 37" descr="09_about.png"/>
+          <p:cNvPicPr>
+            <a:picLocks noChangeAspect="1"/>
+          </p:cNvPicPr>
+          <p:nvPr/>
+        </p:nvPicPr>
+        <p:blipFill>
+          <a:blip r:embed="rId5"/>
+          <a:stretch>
+            <a:fillRect/>
+          </a:stretch>
+        </p:blipFill>
+        <p:spPr>
+          <a:xfrm>
+            <a:off x="6165342" y="3931920"/>
+            <a:ext cx="3657600" cy="2286000"/>
+          </a:xfrm>
+          <a:prstGeom prst="rect">
+            <a:avLst/>
+          </a:prstGeom>
+          <a:ln w="12700">
+            <a:solidFill>
+              <a:srgbClr val="0A6EBD"/>
+            </a:solidFill>
           </a:ln>
         </p:spPr>
-        <p:style>
-          <a:lnRef idx="1">
-            <a:schemeClr val="accent1"/>
-          </a:lnRef>
-          <a:fillRef idx="3">
-            <a:schemeClr val="accent1"/>
-          </a:fillRef>
-          <a:effectRef idx="2">
-            <a:schemeClr val="accent1"/>
-          </a:effectRef>
-          <a:fontRef idx="minor">
-            <a:schemeClr val="lt1"/>
-          </a:fontRef>
-        </p:style>
-        <p:txBody>
-          <a:bodyPr rtlCol="0" anchor="ctr"/>
-          <a:lstStyle/>
-          <a:p>
-            <a:pPr algn="ctr"/>
-          </a:p>
-        </p:txBody>
-      </p:sp>
-      <p:sp>
-        <p:nvSpPr>
-          <p:cNvPr id="35" name="Rectangle 34"/>
-          <p:cNvSpPr/>
-          <p:nvPr/>
-        </p:nvSpPr>
-        <p:spPr>
-          <a:xfrm>
-            <a:off x="5065776" y="1636776"/>
-            <a:ext cx="1691640" cy="91440"/>
-          </a:xfrm>
-          <a:prstGeom prst="rect">
-            <a:avLst/>
-          </a:prstGeom>
-          <a:solidFill>
-            <a:srgbClr val="E8F4FD"/>
-          </a:solidFill>
-          <a:ln>
-            <a:noFill/>
-          </a:ln>
-        </p:spPr>
-        <p:style>
-          <a:lnRef idx="1">
-            <a:schemeClr val="accent1"/>
-          </a:lnRef>
-          <a:fillRef idx="3">
-            <a:schemeClr val="accent1"/>
-          </a:fillRef>
-          <a:effectRef idx="2">
-            <a:schemeClr val="accent1"/>
-          </a:effectRef>
-          <a:fontRef idx="minor">
-            <a:schemeClr val="lt1"/>
-          </a:fontRef>
-        </p:style>
-        <p:txBody>
-          <a:bodyPr rtlCol="0" anchor="ctr"/>
-          <a:lstStyle/>
-          <a:p>
-            <a:pPr algn="ctr"/>
-          </a:p>
-        </p:txBody>
-      </p:sp>
-      <p:sp>
-        <p:nvSpPr>
-          <p:cNvPr id="36" name="Rectangle 35"/>
-          <p:cNvSpPr/>
-          <p:nvPr/>
-        </p:nvSpPr>
-        <p:spPr>
-          <a:xfrm>
-            <a:off x="5065776" y="1792224"/>
-            <a:ext cx="2057400" cy="91440"/>
-          </a:xfrm>
-          <a:prstGeom prst="rect">
-            <a:avLst/>
-          </a:prstGeom>
-          <a:solidFill>
-            <a:srgbClr val="CCCCCC"/>
-          </a:solidFill>
-          <a:ln>
-            <a:noFill/>
-          </a:ln>
-        </p:spPr>
-        <p:style>
-          <a:lnRef idx="1">
-            <a:schemeClr val="accent1"/>
-          </a:lnRef>
-          <a:fillRef idx="3">
-            <a:schemeClr val="accent1"/>
-          </a:fillRef>
-          <a:effectRef idx="2">
-            <a:schemeClr val="accent1"/>
-          </a:effectRef>
-          <a:fontRef idx="minor">
-            <a:schemeClr val="lt1"/>
-          </a:fontRef>
-        </p:style>
-        <p:txBody>
-          <a:bodyPr rtlCol="0" anchor="ctr"/>
-          <a:lstStyle/>
-          <a:p>
-            <a:pPr algn="ctr"/>
-          </a:p>
-        </p:txBody>
-      </p:sp>
-      <p:sp>
-        <p:nvSpPr>
-          <p:cNvPr id="37" name="Rectangle 36"/>
-          <p:cNvSpPr/>
-          <p:nvPr/>
-        </p:nvSpPr>
-        <p:spPr>
-          <a:xfrm>
-            <a:off x="5065776" y="1947672"/>
-            <a:ext cx="1691640" cy="91440"/>
-          </a:xfrm>
-          <a:prstGeom prst="rect">
-            <a:avLst/>
-          </a:prstGeom>
-          <a:solidFill>
-            <a:srgbClr val="CCCCCC"/>
-          </a:solidFill>
-          <a:ln>
-            <a:noFill/>
-          </a:ln>
-        </p:spPr>
-        <p:style>
-          <a:lnRef idx="1">
-            <a:schemeClr val="accent1"/>
-          </a:lnRef>
-          <a:fillRef idx="3">
-            <a:schemeClr val="accent1"/>
-          </a:fillRef>
-          <a:effectRef idx="2">
-            <a:schemeClr val="accent1"/>
-          </a:effectRef>
-          <a:fontRef idx="minor">
-            <a:schemeClr val="lt1"/>
-          </a:fontRef>
-        </p:style>
-        <p:txBody>
-          <a:bodyPr rtlCol="0" anchor="ctr"/>
-          <a:lstStyle/>
-          <a:p>
-            <a:pPr algn="ctr"/>
-          </a:p>
-        </p:txBody>
-      </p:sp>
-      <p:sp>
-        <p:nvSpPr>
-          <p:cNvPr id="38" name="TextBox 37"/>
-          <p:cNvSpPr txBox="1"/>
-          <p:nvPr/>
-        </p:nvSpPr>
-        <p:spPr>
-          <a:xfrm>
-            <a:off x="4974336" y="2194560"/>
-            <a:ext cx="2240280" cy="292608"/>
-          </a:xfrm>
-          <a:prstGeom prst="rect">
-            <a:avLst/>
-          </a:prstGeom>
-          <a:noFill/>
-        </p:spPr>
-        <p:txBody>
-          <a:bodyPr wrap="square">
-            <a:spAutoFit/>
-          </a:bodyPr>
-          <a:lstStyle/>
-          <a:p>
-            <a:pPr algn="l"/>
-            <a:r>
-              <a:rPr sz="1000" b="1" i="0">
+      </p:pic>
+      <p:sp>
+        <p:nvSpPr>
+          <p:cNvPr id="39" name="TextBox 38"/>
+          <p:cNvSpPr txBox="1"/>
+          <p:nvPr/>
+        </p:nvSpPr>
+        <p:spPr>
+          <a:xfrm>
+            <a:off x="6165342" y="6254496"/>
+            <a:ext cx="3657600" cy="274320"/>
+          </a:xfrm>
+          <a:prstGeom prst="rect">
+            <a:avLst/>
+          </a:prstGeom>
+          <a:noFill/>
+        </p:spPr>
+        <p:txBody>
+          <a:bodyPr wrap="square">
+            <a:spAutoFit/>
+          </a:bodyPr>
+          <a:lstStyle/>
+          <a:p>
+            <a:pPr algn="ctr"/>
+            <a:r>
+              <a:rPr sz="1000" b="1">
                 <a:solidFill>
                   <a:srgbClr val="0A6EBD"/>
                 </a:solidFill>
                 <a:latin typeface="Calibri"/>
               </a:rPr>
-              <a:t>3. Human Approval Interface</a:t>
-            </a:r>
-          </a:p>
-        </p:txBody>
-      </p:sp>
-      <p:sp>
-        <p:nvSpPr>
-          <p:cNvPr id="39" name="TextBox 38"/>
-          <p:cNvSpPr txBox="1"/>
-          <p:nvPr/>
-        </p:nvSpPr>
-        <p:spPr>
-          <a:xfrm>
-            <a:off x="4974336" y="2514600"/>
-            <a:ext cx="2240280" cy="960120"/>
-          </a:xfrm>
-          <a:prstGeom prst="rect">
-            <a:avLst/>
-          </a:prstGeom>
-          <a:noFill/>
-        </p:spPr>
-        <p:txBody>
-          <a:bodyPr wrap="square">
-            <a:spAutoFit/>
-          </a:bodyPr>
-          <a:lstStyle/>
-          <a:p>
-            <a:pPr>
-              <a:spcBef>
-                <a:spcPts val="100"/>
-              </a:spcBef>
-            </a:pPr>
-            <a:r>
-              <a:rPr sz="900">
-                <a:solidFill>
-                  <a:srgbClr val="1A1A2E"/>
-                </a:solidFill>
-                <a:latin typeface="Calibri"/>
-              </a:rPr>
-              <a:t>• Radio: Approve | Reject | Override Approve | Override Reject</a:t>
-            </a:r>
-          </a:p>
-          <a:p>
-            <a:pPr>
-              <a:spcBef>
-                <a:spcPts val="100"/>
-              </a:spcBef>
-            </a:pPr>
-            <a:r>
-              <a:rPr sz="900">
-                <a:solidFill>
-                  <a:srgbClr val="1A1A2E"/>
-                </a:solidFill>
-                <a:latin typeface="Calibri"/>
-              </a:rPr>
-              <a:t>• Notes textarea (mandatory for overrides)</a:t>
-            </a:r>
-          </a:p>
-          <a:p>
-            <a:pPr>
-              <a:spcBef>
-                <a:spcPts val="100"/>
-              </a:spcBef>
-            </a:pPr>
-            <a:r>
-              <a:rPr sz="900">
-                <a:solidFill>
-                  <a:srgbClr val="1A1A2E"/>
-                </a:solidFill>
-                <a:latin typeface="Calibri"/>
-              </a:rPr>
-              <a:t>• Submit button disabled until selection made</a:t>
-            </a:r>
-          </a:p>
-          <a:p>
-            <a:pPr>
-              <a:spcBef>
-                <a:spcPts val="100"/>
-              </a:spcBef>
-            </a:pPr>
-            <a:r>
-              <a:rPr sz="900">
-                <a:solidFill>
-                  <a:srgbClr val="1A1A2E"/>
-                </a:solidFill>
-                <a:latin typeface="Calibri"/>
-              </a:rPr>
-              <a:t>• Override warning banner with justification prompt</a:t>
-            </a:r>
-          </a:p>
-        </p:txBody>
-      </p:sp>
-      <p:sp>
-        <p:nvSpPr>
-          <p:cNvPr id="40" name="Rectangle 39"/>
-          <p:cNvSpPr/>
-          <p:nvPr/>
-        </p:nvSpPr>
-        <p:spPr>
-          <a:xfrm>
-            <a:off x="274320" y="3657600"/>
-            <a:ext cx="2240280" cy="960120"/>
-          </a:xfrm>
-          <a:prstGeom prst="rect">
-            <a:avLst/>
-          </a:prstGeom>
-          <a:solidFill>
-            <a:srgbClr val="1A1A2E"/>
-          </a:solidFill>
-          <a:ln>
-            <a:noFill/>
-          </a:ln>
-        </p:spPr>
-        <p:style>
-          <a:lnRef idx="1">
-            <a:schemeClr val="accent1"/>
-          </a:lnRef>
-          <a:fillRef idx="3">
-            <a:schemeClr val="accent1"/>
-          </a:fillRef>
-          <a:effectRef idx="2">
-            <a:schemeClr val="accent1"/>
-          </a:effectRef>
-          <a:fontRef idx="minor">
-            <a:schemeClr val="lt1"/>
-          </a:fontRef>
-        </p:style>
-        <p:txBody>
-          <a:bodyPr rtlCol="0" anchor="ctr"/>
-          <a:lstStyle/>
-          <a:p>
-            <a:pPr algn="ctr"/>
-          </a:p>
-        </p:txBody>
-      </p:sp>
-      <p:sp>
-        <p:nvSpPr>
-          <p:cNvPr id="41" name="Rectangle 40"/>
-          <p:cNvSpPr/>
-          <p:nvPr/>
-        </p:nvSpPr>
-        <p:spPr>
-          <a:xfrm>
-            <a:off x="329184" y="3712463"/>
-            <a:ext cx="2130552" cy="164592"/>
-          </a:xfrm>
-          <a:prstGeom prst="rect">
-            <a:avLst/>
-          </a:prstGeom>
-          <a:solidFill>
-            <a:srgbClr val="0A6EBD"/>
-          </a:solidFill>
-          <a:ln>
-            <a:noFill/>
-          </a:ln>
-        </p:spPr>
-        <p:style>
-          <a:lnRef idx="1">
-            <a:schemeClr val="accent1"/>
-          </a:lnRef>
-          <a:fillRef idx="3">
-            <a:schemeClr val="accent1"/>
-          </a:fillRef>
-          <a:effectRef idx="2">
-            <a:schemeClr val="accent1"/>
-          </a:effectRef>
-          <a:fontRef idx="minor">
-            <a:schemeClr val="lt1"/>
-          </a:fontRef>
-        </p:style>
-        <p:txBody>
-          <a:bodyPr rtlCol="0" anchor="ctr"/>
-          <a:lstStyle/>
-          <a:p>
-            <a:pPr algn="ctr"/>
-          </a:p>
-        </p:txBody>
-      </p:sp>
-      <p:sp>
-        <p:nvSpPr>
-          <p:cNvPr id="42" name="Rectangle 41"/>
-          <p:cNvSpPr/>
-          <p:nvPr/>
-        </p:nvSpPr>
-        <p:spPr>
-          <a:xfrm>
-            <a:off x="356616" y="3739896"/>
-            <a:ext cx="64008" cy="64008"/>
-          </a:xfrm>
-          <a:prstGeom prst="rect">
-            <a:avLst/>
-          </a:prstGeom>
-          <a:solidFill>
-            <a:srgbClr val="FFFFFF"/>
-          </a:solidFill>
-          <a:ln>
-            <a:noFill/>
-          </a:ln>
-        </p:spPr>
-        <p:style>
-          <a:lnRef idx="1">
-            <a:schemeClr val="accent1"/>
-          </a:lnRef>
-          <a:fillRef idx="3">
-            <a:schemeClr val="accent1"/>
-          </a:fillRef>
-          <a:effectRef idx="2">
-            <a:schemeClr val="accent1"/>
-          </a:effectRef>
-          <a:fontRef idx="minor">
-            <a:schemeClr val="lt1"/>
-          </a:fontRef>
-        </p:style>
-        <p:txBody>
-          <a:bodyPr rtlCol="0" anchor="ctr"/>
-          <a:lstStyle/>
-          <a:p>
-            <a:pPr algn="ctr"/>
-          </a:p>
-        </p:txBody>
-      </p:sp>
-      <p:sp>
-        <p:nvSpPr>
-          <p:cNvPr id="43" name="Rectangle 42"/>
-          <p:cNvSpPr/>
-          <p:nvPr/>
-        </p:nvSpPr>
-        <p:spPr>
-          <a:xfrm>
-            <a:off x="448056" y="3739896"/>
-            <a:ext cx="64008" cy="64008"/>
-          </a:xfrm>
-          <a:prstGeom prst="rect">
-            <a:avLst/>
-          </a:prstGeom>
-          <a:solidFill>
-            <a:srgbClr val="FFFFFF"/>
-          </a:solidFill>
-          <a:ln>
-            <a:noFill/>
-          </a:ln>
-        </p:spPr>
-        <p:style>
-          <a:lnRef idx="1">
-            <a:schemeClr val="accent1"/>
-          </a:lnRef>
-          <a:fillRef idx="3">
-            <a:schemeClr val="accent1"/>
-          </a:fillRef>
-          <a:effectRef idx="2">
-            <a:schemeClr val="accent1"/>
-          </a:effectRef>
-          <a:fontRef idx="minor">
-            <a:schemeClr val="lt1"/>
-          </a:fontRef>
-        </p:style>
-        <p:txBody>
-          <a:bodyPr rtlCol="0" anchor="ctr"/>
-          <a:lstStyle/>
-          <a:p>
-            <a:pPr algn="ctr"/>
-          </a:p>
-        </p:txBody>
-      </p:sp>
-      <p:sp>
-        <p:nvSpPr>
-          <p:cNvPr id="44" name="Rectangle 43"/>
-          <p:cNvSpPr/>
-          <p:nvPr/>
-        </p:nvSpPr>
-        <p:spPr>
-          <a:xfrm>
-            <a:off x="539496" y="3739896"/>
-            <a:ext cx="64008" cy="64008"/>
-          </a:xfrm>
-          <a:prstGeom prst="rect">
-            <a:avLst/>
-          </a:prstGeom>
-          <a:solidFill>
-            <a:srgbClr val="FFFFFF"/>
-          </a:solidFill>
-          <a:ln>
-            <a:noFill/>
-          </a:ln>
-        </p:spPr>
-        <p:style>
-          <a:lnRef idx="1">
-            <a:schemeClr val="accent1"/>
-          </a:lnRef>
-          <a:fillRef idx="3">
-            <a:schemeClr val="accent1"/>
-          </a:fillRef>
-          <a:effectRef idx="2">
-            <a:schemeClr val="accent1"/>
-          </a:effectRef>
-          <a:fontRef idx="minor">
-            <a:schemeClr val="lt1"/>
-          </a:fontRef>
-        </p:style>
-        <p:txBody>
-          <a:bodyPr rtlCol="0" anchor="ctr"/>
-          <a:lstStyle/>
-          <a:p>
-            <a:pPr algn="ctr"/>
-          </a:p>
-        </p:txBody>
-      </p:sp>
-      <p:sp>
-        <p:nvSpPr>
-          <p:cNvPr id="45" name="Rectangle 44"/>
-          <p:cNvSpPr/>
-          <p:nvPr/>
-        </p:nvSpPr>
-        <p:spPr>
-          <a:xfrm>
-            <a:off x="365760" y="3950208"/>
-            <a:ext cx="2057400" cy="91440"/>
-          </a:xfrm>
-          <a:prstGeom prst="rect">
-            <a:avLst/>
-          </a:prstGeom>
-          <a:solidFill>
-            <a:srgbClr val="E8F4FD"/>
-          </a:solidFill>
-          <a:ln>
-            <a:noFill/>
-          </a:ln>
-        </p:spPr>
-        <p:style>
-          <a:lnRef idx="1">
-            <a:schemeClr val="accent1"/>
-          </a:lnRef>
-          <a:fillRef idx="3">
-            <a:schemeClr val="accent1"/>
-          </a:fillRef>
-          <a:effectRef idx="2">
-            <a:schemeClr val="accent1"/>
-          </a:effectRef>
-          <a:fontRef idx="minor">
-            <a:schemeClr val="lt1"/>
-          </a:fontRef>
-        </p:style>
-        <p:txBody>
-          <a:bodyPr rtlCol="0" anchor="ctr"/>
-          <a:lstStyle/>
-          <a:p>
-            <a:pPr algn="ctr"/>
-          </a:p>
-        </p:txBody>
-      </p:sp>
-      <p:sp>
-        <p:nvSpPr>
-          <p:cNvPr id="46" name="Rectangle 45"/>
-          <p:cNvSpPr/>
-          <p:nvPr/>
-        </p:nvSpPr>
-        <p:spPr>
-          <a:xfrm>
-            <a:off x="365760" y="4105656"/>
-            <a:ext cx="1691640" cy="91440"/>
-          </a:xfrm>
-          <a:prstGeom prst="rect">
-            <a:avLst/>
-          </a:prstGeom>
-          <a:solidFill>
-            <a:srgbClr val="E8F4FD"/>
-          </a:solidFill>
-          <a:ln>
-            <a:noFill/>
-          </a:ln>
-        </p:spPr>
-        <p:style>
-          <a:lnRef idx="1">
-            <a:schemeClr val="accent1"/>
-          </a:lnRef>
-          <a:fillRef idx="3">
-            <a:schemeClr val="accent1"/>
-          </a:fillRef>
-          <a:effectRef idx="2">
-            <a:schemeClr val="accent1"/>
-          </a:effectRef>
-          <a:fontRef idx="minor">
-            <a:schemeClr val="lt1"/>
-          </a:fontRef>
-        </p:style>
-        <p:txBody>
-          <a:bodyPr rtlCol="0" anchor="ctr"/>
-          <a:lstStyle/>
-          <a:p>
-            <a:pPr algn="ctr"/>
-          </a:p>
-        </p:txBody>
-      </p:sp>
-      <p:sp>
-        <p:nvSpPr>
-          <p:cNvPr id="47" name="Rectangle 46"/>
-          <p:cNvSpPr/>
-          <p:nvPr/>
-        </p:nvSpPr>
-        <p:spPr>
-          <a:xfrm>
-            <a:off x="365760" y="4261104"/>
-            <a:ext cx="2057400" cy="91440"/>
-          </a:xfrm>
-          <a:prstGeom prst="rect">
-            <a:avLst/>
-          </a:prstGeom>
-          <a:solidFill>
-            <a:srgbClr val="CCCCCC"/>
-          </a:solidFill>
-          <a:ln>
-            <a:noFill/>
-          </a:ln>
-        </p:spPr>
-        <p:style>
-          <a:lnRef idx="1">
-            <a:schemeClr val="accent1"/>
-          </a:lnRef>
-          <a:fillRef idx="3">
-            <a:schemeClr val="accent1"/>
-          </a:fillRef>
-          <a:effectRef idx="2">
-            <a:schemeClr val="accent1"/>
-          </a:effectRef>
-          <a:fontRef idx="minor">
-            <a:schemeClr val="lt1"/>
-          </a:fontRef>
-        </p:style>
-        <p:txBody>
-          <a:bodyPr rtlCol="0" anchor="ctr"/>
-          <a:lstStyle/>
-          <a:p>
-            <a:pPr algn="ctr"/>
-          </a:p>
-        </p:txBody>
-      </p:sp>
-      <p:sp>
-        <p:nvSpPr>
-          <p:cNvPr id="48" name="Rectangle 47"/>
-          <p:cNvSpPr/>
-          <p:nvPr/>
-        </p:nvSpPr>
-        <p:spPr>
-          <a:xfrm>
-            <a:off x="365760" y="4416552"/>
-            <a:ext cx="1691640" cy="91440"/>
-          </a:xfrm>
-          <a:prstGeom prst="rect">
-            <a:avLst/>
-          </a:prstGeom>
-          <a:solidFill>
-            <a:srgbClr val="CCCCCC"/>
-          </a:solidFill>
-          <a:ln>
-            <a:noFill/>
-          </a:ln>
-        </p:spPr>
-        <p:style>
-          <a:lnRef idx="1">
-            <a:schemeClr val="accent1"/>
-          </a:lnRef>
-          <a:fillRef idx="3">
-            <a:schemeClr val="accent1"/>
-          </a:fillRef>
-          <a:effectRef idx="2">
-            <a:schemeClr val="accent1"/>
-          </a:effectRef>
-          <a:fontRef idx="minor">
-            <a:schemeClr val="lt1"/>
-          </a:fontRef>
-        </p:style>
-        <p:txBody>
-          <a:bodyPr rtlCol="0" anchor="ctr"/>
-          <a:lstStyle/>
-          <a:p>
-            <a:pPr algn="ctr"/>
-          </a:p>
-        </p:txBody>
-      </p:sp>
-      <p:sp>
-        <p:nvSpPr>
-          <p:cNvPr id="49" name="TextBox 48"/>
-          <p:cNvSpPr txBox="1"/>
-          <p:nvPr/>
-        </p:nvSpPr>
-        <p:spPr>
-          <a:xfrm>
-            <a:off x="274320" y="4663440"/>
-            <a:ext cx="2240280" cy="292608"/>
-          </a:xfrm>
-          <a:prstGeom prst="rect">
-            <a:avLst/>
-          </a:prstGeom>
-          <a:noFill/>
-        </p:spPr>
-        <p:txBody>
-          <a:bodyPr wrap="square">
-            <a:spAutoFit/>
-          </a:bodyPr>
-          <a:lstStyle/>
-          <a:p>
-            <a:pPr algn="l"/>
-            <a:r>
-              <a:rPr sz="1000" b="1" i="0">
-                <a:solidFill>
-                  <a:srgbClr val="0A6EBD"/>
-                </a:solidFill>
-                <a:latin typeface="Calibri"/>
-              </a:rPr>
-              <a:t>4. Claims History Dashboard</a:t>
-            </a:r>
-          </a:p>
-        </p:txBody>
-      </p:sp>
-      <p:sp>
-        <p:nvSpPr>
-          <p:cNvPr id="50" name="TextBox 49"/>
-          <p:cNvSpPr txBox="1"/>
-          <p:nvPr/>
-        </p:nvSpPr>
-        <p:spPr>
-          <a:xfrm>
-            <a:off x="274320" y="4983480"/>
-            <a:ext cx="2240280" cy="960120"/>
-          </a:xfrm>
-          <a:prstGeom prst="rect">
-            <a:avLst/>
-          </a:prstGeom>
-          <a:noFill/>
-        </p:spPr>
-        <p:txBody>
-          <a:bodyPr wrap="square">
-            <a:spAutoFit/>
-          </a:bodyPr>
-          <a:lstStyle/>
-          <a:p>
-            <a:pPr>
-              <a:spcBef>
-                <a:spcPts val="100"/>
-              </a:spcBef>
-            </a:pPr>
-            <a:r>
-              <a:rPr sz="900">
-                <a:solidFill>
-                  <a:srgbClr val="1A1A2E"/>
-                </a:solidFill>
-                <a:latin typeface="Calibri"/>
-              </a:rPr>
-              <a:t>• Total / Approved / Rejected / Manual Review counts</a:t>
-            </a:r>
-          </a:p>
-          <a:p>
-            <a:pPr>
-              <a:spcBef>
-                <a:spcPts val="100"/>
-              </a:spcBef>
-            </a:pPr>
-            <a:r>
-              <a:rPr sz="900">
-                <a:solidFill>
-                  <a:srgbClr val="1A1A2E"/>
-                </a:solidFill>
-                <a:latin typeface="Calibri"/>
-              </a:rPr>
-              <a:t>• AI Agreement Rate metric</a:t>
-            </a:r>
-          </a:p>
-          <a:p>
-            <a:pPr>
-              <a:spcBef>
-                <a:spcPts val="100"/>
-              </a:spcBef>
-            </a:pPr>
-            <a:r>
-              <a:rPr sz="900">
-                <a:solidFill>
-                  <a:srgbClr val="1A1A2E"/>
-                </a:solidFill>
-                <a:latin typeface="Calibri"/>
-              </a:rPr>
-              <a:t>• Sortable colour-coded table (green/red/yellow)</a:t>
-            </a:r>
-          </a:p>
-          <a:p>
-            <a:pPr>
-              <a:spcBef>
-                <a:spcPts val="100"/>
-              </a:spcBef>
-            </a:pPr>
-            <a:r>
-              <a:rPr sz="900">
-                <a:solidFill>
-                  <a:srgbClr val="1A1A2E"/>
-                </a:solidFill>
-                <a:latin typeface="Calibri"/>
-              </a:rPr>
-              <a:t>• Export functionality for audit records</a:t>
-            </a:r>
-          </a:p>
-        </p:txBody>
-      </p:sp>
-      <p:sp>
-        <p:nvSpPr>
-          <p:cNvPr id="51" name="Rectangle 50"/>
-          <p:cNvSpPr/>
-          <p:nvPr/>
-        </p:nvSpPr>
-        <p:spPr>
-          <a:xfrm>
-            <a:off x="2624328" y="3657600"/>
-            <a:ext cx="2240280" cy="960120"/>
-          </a:xfrm>
-          <a:prstGeom prst="rect">
-            <a:avLst/>
-          </a:prstGeom>
-          <a:solidFill>
-            <a:srgbClr val="1A1A2E"/>
-          </a:solidFill>
-          <a:ln>
-            <a:noFill/>
-          </a:ln>
-        </p:spPr>
-        <p:style>
-          <a:lnRef idx="1">
-            <a:schemeClr val="accent1"/>
-          </a:lnRef>
-          <a:fillRef idx="3">
-            <a:schemeClr val="accent1"/>
-          </a:fillRef>
-          <a:effectRef idx="2">
-            <a:schemeClr val="accent1"/>
-          </a:effectRef>
-          <a:fontRef idx="minor">
-            <a:schemeClr val="lt1"/>
-          </a:fontRef>
-        </p:style>
-        <p:txBody>
-          <a:bodyPr rtlCol="0" anchor="ctr"/>
-          <a:lstStyle/>
-          <a:p>
-            <a:pPr algn="ctr"/>
-          </a:p>
-        </p:txBody>
-      </p:sp>
-      <p:sp>
-        <p:nvSpPr>
-          <p:cNvPr id="52" name="Rectangle 51"/>
-          <p:cNvSpPr/>
-          <p:nvPr/>
-        </p:nvSpPr>
-        <p:spPr>
-          <a:xfrm>
-            <a:off x="2679192" y="3712463"/>
-            <a:ext cx="2130552" cy="164592"/>
-          </a:xfrm>
-          <a:prstGeom prst="rect">
-            <a:avLst/>
-          </a:prstGeom>
-          <a:solidFill>
-            <a:srgbClr val="0A6EBD"/>
-          </a:solidFill>
-          <a:ln>
-            <a:noFill/>
-          </a:ln>
-        </p:spPr>
-        <p:style>
-          <a:lnRef idx="1">
-            <a:schemeClr val="accent1"/>
-          </a:lnRef>
-          <a:fillRef idx="3">
-            <a:schemeClr val="accent1"/>
-          </a:fillRef>
-          <a:effectRef idx="2">
-            <a:schemeClr val="accent1"/>
-          </a:effectRef>
-          <a:fontRef idx="minor">
-            <a:schemeClr val="lt1"/>
-          </a:fontRef>
-        </p:style>
-        <p:txBody>
-          <a:bodyPr rtlCol="0" anchor="ctr"/>
-          <a:lstStyle/>
-          <a:p>
-            <a:pPr algn="ctr"/>
-          </a:p>
-        </p:txBody>
-      </p:sp>
-      <p:sp>
-        <p:nvSpPr>
-          <p:cNvPr id="53" name="Rectangle 52"/>
-          <p:cNvSpPr/>
-          <p:nvPr/>
-        </p:nvSpPr>
-        <p:spPr>
-          <a:xfrm>
-            <a:off x="2706624" y="3739896"/>
-            <a:ext cx="64008" cy="64008"/>
-          </a:xfrm>
-          <a:prstGeom prst="rect">
-            <a:avLst/>
-          </a:prstGeom>
-          <a:solidFill>
-            <a:srgbClr val="FFFFFF"/>
-          </a:solidFill>
-          <a:ln>
-            <a:noFill/>
-          </a:ln>
-        </p:spPr>
-        <p:style>
-          <a:lnRef idx="1">
-            <a:schemeClr val="accent1"/>
-          </a:lnRef>
-          <a:fillRef idx="3">
-            <a:schemeClr val="accent1"/>
-          </a:fillRef>
-          <a:effectRef idx="2">
-            <a:schemeClr val="accent1"/>
-          </a:effectRef>
-          <a:fontRef idx="minor">
-            <a:schemeClr val="lt1"/>
-          </a:fontRef>
-        </p:style>
-        <p:txBody>
-          <a:bodyPr rtlCol="0" anchor="ctr"/>
-          <a:lstStyle/>
-          <a:p>
-            <a:pPr algn="ctr"/>
-          </a:p>
-        </p:txBody>
-      </p:sp>
-      <p:sp>
-        <p:nvSpPr>
-          <p:cNvPr id="54" name="Rectangle 53"/>
-          <p:cNvSpPr/>
-          <p:nvPr/>
-        </p:nvSpPr>
-        <p:spPr>
-          <a:xfrm>
-            <a:off x="2798064" y="3739896"/>
-            <a:ext cx="64008" cy="64008"/>
-          </a:xfrm>
-          <a:prstGeom prst="rect">
-            <a:avLst/>
-          </a:prstGeom>
-          <a:solidFill>
-            <a:srgbClr val="FFFFFF"/>
-          </a:solidFill>
-          <a:ln>
-            <a:noFill/>
-          </a:ln>
-        </p:spPr>
-        <p:style>
-          <a:lnRef idx="1">
-            <a:schemeClr val="accent1"/>
-          </a:lnRef>
-          <a:fillRef idx="3">
-            <a:schemeClr val="accent1"/>
-          </a:fillRef>
-          <a:effectRef idx="2">
-            <a:schemeClr val="accent1"/>
-          </a:effectRef>
-          <a:fontRef idx="minor">
-            <a:schemeClr val="lt1"/>
-          </a:fontRef>
-        </p:style>
-        <p:txBody>
-          <a:bodyPr rtlCol="0" anchor="ctr"/>
-          <a:lstStyle/>
-          <a:p>
-            <a:pPr algn="ctr"/>
-          </a:p>
-        </p:txBody>
-      </p:sp>
-      <p:sp>
-        <p:nvSpPr>
-          <p:cNvPr id="55" name="Rectangle 54"/>
-          <p:cNvSpPr/>
-          <p:nvPr/>
-        </p:nvSpPr>
-        <p:spPr>
-          <a:xfrm>
-            <a:off x="2889504" y="3739896"/>
-            <a:ext cx="64008" cy="64008"/>
-          </a:xfrm>
-          <a:prstGeom prst="rect">
-            <a:avLst/>
-          </a:prstGeom>
-          <a:solidFill>
-            <a:srgbClr val="FFFFFF"/>
-          </a:solidFill>
-          <a:ln>
-            <a:noFill/>
-          </a:ln>
-        </p:spPr>
-        <p:style>
-          <a:lnRef idx="1">
-            <a:schemeClr val="accent1"/>
-          </a:lnRef>
-          <a:fillRef idx="3">
-            <a:schemeClr val="accent1"/>
-          </a:fillRef>
-          <a:effectRef idx="2">
-            <a:schemeClr val="accent1"/>
-          </a:effectRef>
-          <a:fontRef idx="minor">
-            <a:schemeClr val="lt1"/>
-          </a:fontRef>
-        </p:style>
-        <p:txBody>
-          <a:bodyPr rtlCol="0" anchor="ctr"/>
-          <a:lstStyle/>
-          <a:p>
-            <a:pPr algn="ctr"/>
-          </a:p>
-        </p:txBody>
-      </p:sp>
-      <p:sp>
-        <p:nvSpPr>
-          <p:cNvPr id="56" name="Rectangle 55"/>
-          <p:cNvSpPr/>
-          <p:nvPr/>
-        </p:nvSpPr>
-        <p:spPr>
-          <a:xfrm>
-            <a:off x="2715768" y="3950208"/>
-            <a:ext cx="2057400" cy="91440"/>
-          </a:xfrm>
-          <a:prstGeom prst="rect">
-            <a:avLst/>
-          </a:prstGeom>
-          <a:solidFill>
-            <a:srgbClr val="E8F4FD"/>
-          </a:solidFill>
-          <a:ln>
-            <a:noFill/>
-          </a:ln>
-        </p:spPr>
-        <p:style>
-          <a:lnRef idx="1">
-            <a:schemeClr val="accent1"/>
-          </a:lnRef>
-          <a:fillRef idx="3">
-            <a:schemeClr val="accent1"/>
-          </a:fillRef>
-          <a:effectRef idx="2">
-            <a:schemeClr val="accent1"/>
-          </a:effectRef>
-          <a:fontRef idx="minor">
-            <a:schemeClr val="lt1"/>
-          </a:fontRef>
-        </p:style>
-        <p:txBody>
-          <a:bodyPr rtlCol="0" anchor="ctr"/>
-          <a:lstStyle/>
-          <a:p>
-            <a:pPr algn="ctr"/>
-          </a:p>
-        </p:txBody>
-      </p:sp>
-      <p:sp>
-        <p:nvSpPr>
-          <p:cNvPr id="57" name="Rectangle 56"/>
-          <p:cNvSpPr/>
-          <p:nvPr/>
-        </p:nvSpPr>
-        <p:spPr>
-          <a:xfrm>
-            <a:off x="2715768" y="4105656"/>
-            <a:ext cx="1691640" cy="91440"/>
-          </a:xfrm>
-          <a:prstGeom prst="rect">
-            <a:avLst/>
-          </a:prstGeom>
-          <a:solidFill>
-            <a:srgbClr val="E8F4FD"/>
-          </a:solidFill>
-          <a:ln>
-            <a:noFill/>
-          </a:ln>
-        </p:spPr>
-        <p:style>
-          <a:lnRef idx="1">
-            <a:schemeClr val="accent1"/>
-          </a:lnRef>
-          <a:fillRef idx="3">
-            <a:schemeClr val="accent1"/>
-          </a:fillRef>
-          <a:effectRef idx="2">
-            <a:schemeClr val="accent1"/>
-          </a:effectRef>
-          <a:fontRef idx="minor">
-            <a:schemeClr val="lt1"/>
-          </a:fontRef>
-        </p:style>
-        <p:txBody>
-          <a:bodyPr rtlCol="0" anchor="ctr"/>
-          <a:lstStyle/>
-          <a:p>
-            <a:pPr algn="ctr"/>
-          </a:p>
-        </p:txBody>
-      </p:sp>
-      <p:sp>
-        <p:nvSpPr>
-          <p:cNvPr id="58" name="Rectangle 57"/>
-          <p:cNvSpPr/>
-          <p:nvPr/>
-        </p:nvSpPr>
-        <p:spPr>
-          <a:xfrm>
-            <a:off x="2715768" y="4261104"/>
-            <a:ext cx="2057400" cy="91440"/>
-          </a:xfrm>
-          <a:prstGeom prst="rect">
-            <a:avLst/>
-          </a:prstGeom>
-          <a:solidFill>
-            <a:srgbClr val="CCCCCC"/>
-          </a:solidFill>
-          <a:ln>
-            <a:noFill/>
-          </a:ln>
-        </p:spPr>
-        <p:style>
-          <a:lnRef idx="1">
-            <a:schemeClr val="accent1"/>
-          </a:lnRef>
-          <a:fillRef idx="3">
-            <a:schemeClr val="accent1"/>
-          </a:fillRef>
-          <a:effectRef idx="2">
-            <a:schemeClr val="accent1"/>
-          </a:effectRef>
-          <a:fontRef idx="minor">
-            <a:schemeClr val="lt1"/>
-          </a:fontRef>
-        </p:style>
-        <p:txBody>
-          <a:bodyPr rtlCol="0" anchor="ctr"/>
-          <a:lstStyle/>
-          <a:p>
-            <a:pPr algn="ctr"/>
-          </a:p>
-        </p:txBody>
-      </p:sp>
-      <p:sp>
-        <p:nvSpPr>
-          <p:cNvPr id="59" name="Rectangle 58"/>
-          <p:cNvSpPr/>
-          <p:nvPr/>
-        </p:nvSpPr>
-        <p:spPr>
-          <a:xfrm>
-            <a:off x="2715768" y="4416552"/>
-            <a:ext cx="1691640" cy="91440"/>
-          </a:xfrm>
-          <a:prstGeom prst="rect">
-            <a:avLst/>
-          </a:prstGeom>
-          <a:solidFill>
-            <a:srgbClr val="CCCCCC"/>
-          </a:solidFill>
-          <a:ln>
-            <a:noFill/>
-          </a:ln>
-        </p:spPr>
-        <p:style>
-          <a:lnRef idx="1">
-            <a:schemeClr val="accent1"/>
-          </a:lnRef>
-          <a:fillRef idx="3">
-            <a:schemeClr val="accent1"/>
-          </a:fillRef>
-          <a:effectRef idx="2">
-            <a:schemeClr val="accent1"/>
-          </a:effectRef>
-          <a:fontRef idx="minor">
-            <a:schemeClr val="lt1"/>
-          </a:fontRef>
-        </p:style>
-        <p:txBody>
-          <a:bodyPr rtlCol="0" anchor="ctr"/>
-          <a:lstStyle/>
-          <a:p>
-            <a:pPr algn="ctr"/>
-          </a:p>
-        </p:txBody>
-      </p:sp>
-      <p:sp>
-        <p:nvSpPr>
-          <p:cNvPr id="60" name="TextBox 59"/>
-          <p:cNvSpPr txBox="1"/>
-          <p:nvPr/>
-        </p:nvSpPr>
-        <p:spPr>
-          <a:xfrm>
-            <a:off x="2624328" y="4663440"/>
-            <a:ext cx="2240280" cy="292608"/>
-          </a:xfrm>
-          <a:prstGeom prst="rect">
-            <a:avLst/>
-          </a:prstGeom>
-          <a:noFill/>
-        </p:spPr>
-        <p:txBody>
-          <a:bodyPr wrap="square">
-            <a:spAutoFit/>
-          </a:bodyPr>
-          <a:lstStyle/>
-          <a:p>
-            <a:pPr algn="l"/>
-            <a:r>
-              <a:rPr sz="1000" b="1" i="0">
-                <a:solidFill>
-                  <a:srgbClr val="0A6EBD"/>
-                </a:solidFill>
-                <a:latin typeface="Calibri"/>
-              </a:rPr>
-              <a:t>5. About / System Info</a:t>
-            </a:r>
-          </a:p>
-        </p:txBody>
-      </p:sp>
-      <p:sp>
-        <p:nvSpPr>
-          <p:cNvPr id="61" name="TextBox 60"/>
-          <p:cNvSpPr txBox="1"/>
-          <p:nvPr/>
-        </p:nvSpPr>
-        <p:spPr>
-          <a:xfrm>
-            <a:off x="2624328" y="4983480"/>
-            <a:ext cx="2240280" cy="960120"/>
-          </a:xfrm>
-          <a:prstGeom prst="rect">
-            <a:avLst/>
-          </a:prstGeom>
-          <a:noFill/>
-        </p:spPr>
-        <p:txBody>
-          <a:bodyPr wrap="square">
-            <a:spAutoFit/>
-          </a:bodyPr>
-          <a:lstStyle/>
-          <a:p>
-            <a:pPr>
-              <a:spcBef>
-                <a:spcPts val="100"/>
-              </a:spcBef>
-            </a:pPr>
-            <a:r>
-              <a:rPr sz="900">
-                <a:solidFill>
-                  <a:srgbClr val="1A1A2E"/>
-                </a:solidFill>
-                <a:latin typeface="Calibri"/>
-              </a:rPr>
-              <a:t>• Technology stack with version info</a:t>
-            </a:r>
-          </a:p>
-          <a:p>
-            <a:pPr>
-              <a:spcBef>
-                <a:spcPts val="100"/>
-              </a:spcBef>
-            </a:pPr>
-            <a:r>
-              <a:rPr sz="900">
-                <a:solidFill>
-                  <a:srgbClr val="1A1A2E"/>
-                </a:solidFill>
-                <a:latin typeface="Calibri"/>
-              </a:rPr>
-              <a:t>• Pipeline diagram</a:t>
-            </a:r>
-          </a:p>
-          <a:p>
-            <a:pPr>
-              <a:spcBef>
-                <a:spcPts val="100"/>
-              </a:spcBef>
-            </a:pPr>
-            <a:r>
-              <a:rPr sz="900">
-                <a:solidFill>
-                  <a:srgbClr val="1A1A2E"/>
-                </a:solidFill>
-                <a:latin typeface="Calibri"/>
-              </a:rPr>
-              <a:t>• Supported claim scenarios and expected outcomes</a:t>
-            </a:r>
-          </a:p>
-          <a:p>
-            <a:pPr>
-              <a:spcBef>
-                <a:spcPts val="100"/>
-              </a:spcBef>
-            </a:pPr>
-            <a:r>
-              <a:rPr sz="900">
-                <a:solidFill>
-                  <a:srgbClr val="1A1A2E"/>
-                </a:solidFill>
-                <a:latin typeface="Calibri"/>
-              </a:rPr>
-              <a:t>• Team credits</a:t>
+              <a:t>5. About &amp; System Information</a:t>
             </a:r>
           </a:p>
         </p:txBody>

</xml_diff>

<commit_message>
Replace presentation with demo video embedded version
Slide 9 now contains the live mp4 demo video replacing static screenshots.
Removes the temporary _new.pptx file.

Co-Authored-By: Claude Sonnet 4.6 <noreply@anthropic.com>
</commit_message>
<xml_diff>
--- a/ClaimIQ_Presentation.pptx
+++ b/ClaimIQ_Presentation.pptx
@@ -20029,31 +20029,35 @@
       </p:sp>
       <p:pic>
         <p:nvPicPr>
-          <p:cNvPr id="30" name="Picture 29" descr="01_home.png"/>
+          <p:cNvPr id="30" name="claimiq_demo.mp4">
+            <a:hlinkClick r:id="" action="ppaction://media"/>
+          </p:cNvPr>
           <p:cNvPicPr>
             <a:picLocks noChangeAspect="1"/>
           </p:cNvPicPr>
-          <p:nvPr/>
+          <p:nvPr>
+            <a:videoFile r:link="rId7"/>
+            <p:extLst>
+              <p:ext uri="{DAA4B4D4-6D71-4841-9C94-3DE7FCFB9230}">
+                <p14:media xmlns:p14="http://schemas.microsoft.com/office/powerpoint/2010/main" r:embed="rId6"/>
+              </p:ext>
+            </p:extLst>
+          </p:nvPr>
         </p:nvPicPr>
         <p:blipFill>
-          <a:blip r:embed="rId2"/>
+          <a:blip r:embed="rId8"/>
           <a:stretch>
             <a:fillRect/>
           </a:stretch>
         </p:blipFill>
         <p:spPr>
           <a:xfrm>
-            <a:off x="274320" y="1207008"/>
-            <a:ext cx="3657600" cy="2286000"/>
-          </a:xfrm>
-          <a:prstGeom prst="rect">
-            <a:avLst/>
-          </a:prstGeom>
-          <a:ln w="12700">
-            <a:solidFill>
-              <a:srgbClr val="0A6EBD"/>
-            </a:solidFill>
-          </a:ln>
+            <a:off x="425195" y="1234440"/>
+            <a:ext cx="11338560" cy="5029200"/>
+          </a:xfrm>
+          <a:prstGeom prst="rect">
+            <a:avLst/>
+          </a:prstGeom>
         </p:spPr>
       </p:pic>
       <p:sp>
@@ -20064,285 +20068,29 @@
         </p:nvSpPr>
         <p:spPr>
           <a:xfrm>
-            <a:off x="274320" y="3529584"/>
-            <a:ext cx="3657600" cy="274320"/>
-          </a:xfrm>
-          <a:prstGeom prst="rect">
-            <a:avLst/>
-          </a:prstGeom>
-          <a:noFill/>
-        </p:spPr>
-        <p:txBody>
-          <a:bodyPr wrap="square">
-            <a:spAutoFit/>
-          </a:bodyPr>
-          <a:lstStyle/>
-          <a:p>
-            <a:pPr algn="ctr"/>
-            <a:r>
-              <a:rPr sz="1000" b="1">
+            <a:off x="425195" y="6373368"/>
+            <a:ext cx="11338560" cy="320040"/>
+          </a:xfrm>
+          <a:prstGeom prst="rect">
+            <a:avLst/>
+          </a:prstGeom>
+          <a:noFill/>
+        </p:spPr>
+        <p:txBody>
+          <a:bodyPr wrap="none">
+            <a:spAutoFit/>
+          </a:bodyPr>
+          <a:lstStyle/>
+          <a:p>
+            <a:pPr algn="ctr"/>
+            <a:r>
+              <a:rPr sz="1100" b="1">
                 <a:solidFill>
                   <a:srgbClr val="0A6EBD"/>
                 </a:solidFill>
                 <a:latin typeface="Calibri"/>
               </a:rPr>
-              <a:t>1. Home — Upload &amp; System Status</a:t>
-            </a:r>
-          </a:p>
-        </p:txBody>
-      </p:sp>
-      <p:pic>
-        <p:nvPicPr>
-          <p:cNvPr id="32" name="Picture 31" descr="03_pipeline_complete.png"/>
-          <p:cNvPicPr>
-            <a:picLocks noChangeAspect="1"/>
-          </p:cNvPicPr>
-          <p:nvPr/>
-        </p:nvPicPr>
-        <p:blipFill>
-          <a:blip r:embed="rId3"/>
-          <a:stretch>
-            <a:fillRect/>
-          </a:stretch>
-        </p:blipFill>
-        <p:spPr>
-          <a:xfrm>
-            <a:off x="4073652" y="1207008"/>
-            <a:ext cx="3657600" cy="2286000"/>
-          </a:xfrm>
-          <a:prstGeom prst="rect">
-            <a:avLst/>
-          </a:prstGeom>
-          <a:ln w="12700">
-            <a:solidFill>
-              <a:srgbClr val="0A6EBD"/>
-            </a:solidFill>
-          </a:ln>
-        </p:spPr>
-      </p:pic>
-      <p:sp>
-        <p:nvSpPr>
-          <p:cNvPr id="33" name="TextBox 32"/>
-          <p:cNvSpPr txBox="1"/>
-          <p:nvPr/>
-        </p:nvSpPr>
-        <p:spPr>
-          <a:xfrm>
-            <a:off x="4073652" y="3529584"/>
-            <a:ext cx="3657600" cy="274320"/>
-          </a:xfrm>
-          <a:prstGeom prst="rect">
-            <a:avLst/>
-          </a:prstGeom>
-          <a:noFill/>
-        </p:spPr>
-        <p:txBody>
-          <a:bodyPr wrap="square">
-            <a:spAutoFit/>
-          </a:bodyPr>
-          <a:lstStyle/>
-          <a:p>
-            <a:pPr algn="ctr"/>
-            <a:r>
-              <a:rPr sz="1000" b="1">
-                <a:solidFill>
-                  <a:srgbClr val="0A6EBD"/>
-                </a:solidFill>
-                <a:latin typeface="Calibri"/>
-              </a:rPr>
-              <a:t>2. AI Pipeline — OCR Extraction Results</a:t>
-            </a:r>
-          </a:p>
-        </p:txBody>
-      </p:sp>
-      <p:pic>
-        <p:nvPicPr>
-          <p:cNvPr id="34" name="Picture 33" descr="03_pipeline_complete.png"/>
-          <p:cNvPicPr>
-            <a:picLocks noChangeAspect="1"/>
-          </p:cNvPicPr>
-          <p:nvPr/>
-        </p:nvPicPr>
-        <p:blipFill>
-          <a:blip r:embed="rId3"/>
-          <a:stretch>
-            <a:fillRect/>
-          </a:stretch>
-        </p:blipFill>
-        <p:spPr>
-          <a:xfrm>
-            <a:off x="7872983" y="1207008"/>
-            <a:ext cx="3657600" cy="2286000"/>
-          </a:xfrm>
-          <a:prstGeom prst="rect">
-            <a:avLst/>
-          </a:prstGeom>
-          <a:ln w="12700">
-            <a:solidFill>
-              <a:srgbClr val="0A6EBD"/>
-            </a:solidFill>
-          </a:ln>
-        </p:spPr>
-      </p:pic>
-      <p:sp>
-        <p:nvSpPr>
-          <p:cNvPr id="35" name="TextBox 34"/>
-          <p:cNvSpPr txBox="1"/>
-          <p:nvPr/>
-        </p:nvSpPr>
-        <p:spPr>
-          <a:xfrm>
-            <a:off x="7872983" y="3529584"/>
-            <a:ext cx="3657600" cy="274320"/>
-          </a:xfrm>
-          <a:prstGeom prst="rect">
-            <a:avLst/>
-          </a:prstGeom>
-          <a:noFill/>
-        </p:spPr>
-        <p:txBody>
-          <a:bodyPr wrap="square">
-            <a:spAutoFit/>
-          </a:bodyPr>
-          <a:lstStyle/>
-          <a:p>
-            <a:pPr algn="ctr"/>
-            <a:r>
-              <a:rPr sz="1000" b="1">
-                <a:solidFill>
-                  <a:srgbClr val="0A6EBD"/>
-                </a:solidFill>
-                <a:latin typeface="Calibri"/>
-              </a:rPr>
-              <a:t>3. AI Recommendation &amp; Policy Citations</a:t>
-            </a:r>
-          </a:p>
-        </p:txBody>
-      </p:sp>
-      <p:pic>
-        <p:nvPicPr>
-          <p:cNvPr id="36" name="Picture 35" descr="08_claims_history.png"/>
-          <p:cNvPicPr>
-            <a:picLocks noChangeAspect="1"/>
-          </p:cNvPicPr>
-          <p:nvPr/>
-        </p:nvPicPr>
-        <p:blipFill>
-          <a:blip r:embed="rId4"/>
-          <a:stretch>
-            <a:fillRect/>
-          </a:stretch>
-        </p:blipFill>
-        <p:spPr>
-          <a:xfrm>
-            <a:off x="2366010" y="3931920"/>
-            <a:ext cx="3657600" cy="2286000"/>
-          </a:xfrm>
-          <a:prstGeom prst="rect">
-            <a:avLst/>
-          </a:prstGeom>
-          <a:ln w="12700">
-            <a:solidFill>
-              <a:srgbClr val="0A6EBD"/>
-            </a:solidFill>
-          </a:ln>
-        </p:spPr>
-      </p:pic>
-      <p:sp>
-        <p:nvSpPr>
-          <p:cNvPr id="37" name="TextBox 36"/>
-          <p:cNvSpPr txBox="1"/>
-          <p:nvPr/>
-        </p:nvSpPr>
-        <p:spPr>
-          <a:xfrm>
-            <a:off x="2366010" y="6254496"/>
-            <a:ext cx="3657600" cy="274320"/>
-          </a:xfrm>
-          <a:prstGeom prst="rect">
-            <a:avLst/>
-          </a:prstGeom>
-          <a:noFill/>
-        </p:spPr>
-        <p:txBody>
-          <a:bodyPr wrap="square">
-            <a:spAutoFit/>
-          </a:bodyPr>
-          <a:lstStyle/>
-          <a:p>
-            <a:pPr algn="ctr"/>
-            <a:r>
-              <a:rPr sz="1000" b="1">
-                <a:solidFill>
-                  <a:srgbClr val="0A6EBD"/>
-                </a:solidFill>
-                <a:latin typeface="Calibri"/>
-              </a:rPr>
-              <a:t>4. Claims History Dashboard</a:t>
-            </a:r>
-          </a:p>
-        </p:txBody>
-      </p:sp>
-      <p:pic>
-        <p:nvPicPr>
-          <p:cNvPr id="38" name="Picture 37" descr="09_about.png"/>
-          <p:cNvPicPr>
-            <a:picLocks noChangeAspect="1"/>
-          </p:cNvPicPr>
-          <p:nvPr/>
-        </p:nvPicPr>
-        <p:blipFill>
-          <a:blip r:embed="rId5"/>
-          <a:stretch>
-            <a:fillRect/>
-          </a:stretch>
-        </p:blipFill>
-        <p:spPr>
-          <a:xfrm>
-            <a:off x="6165342" y="3931920"/>
-            <a:ext cx="3657600" cy="2286000"/>
-          </a:xfrm>
-          <a:prstGeom prst="rect">
-            <a:avLst/>
-          </a:prstGeom>
-          <a:ln w="12700">
-            <a:solidFill>
-              <a:srgbClr val="0A6EBD"/>
-            </a:solidFill>
-          </a:ln>
-        </p:spPr>
-      </p:pic>
-      <p:sp>
-        <p:nvSpPr>
-          <p:cNvPr id="39" name="TextBox 38"/>
-          <p:cNvSpPr txBox="1"/>
-          <p:nvPr/>
-        </p:nvSpPr>
-        <p:spPr>
-          <a:xfrm>
-            <a:off x="6165342" y="6254496"/>
-            <a:ext cx="3657600" cy="274320"/>
-          </a:xfrm>
-          <a:prstGeom prst="rect">
-            <a:avLst/>
-          </a:prstGeom>
-          <a:noFill/>
-        </p:spPr>
-        <p:txBody>
-          <a:bodyPr wrap="square">
-            <a:spAutoFit/>
-          </a:bodyPr>
-          <a:lstStyle/>
-          <a:p>
-            <a:pPr algn="ctr"/>
-            <a:r>
-              <a:rPr sz="1000" b="1">
-                <a:solidFill>
-                  <a:srgbClr val="0A6EBD"/>
-                </a:solidFill>
-                <a:latin typeface="Calibri"/>
-              </a:rPr>
-              <a:t>5. About &amp; System Information</a:t>
+              <a:t>Live Demo  |  ClaimIQ on AWS EC2 ap-south-1  |  http://13.206.252.215:8501</a:t>
             </a:r>
           </a:p>
         </p:txBody>
@@ -20352,6 +20100,28 @@
   <p:clrMapOvr>
     <a:masterClrMapping/>
   </p:clrMapOvr>
+  <p:timing>
+    <p:tnLst>
+      <p:par>
+        <p:cTn id="1" dur="indefinite" restart="never" nodeType="tmRoot">
+          <p:childTnLst>
+            <p:video>
+              <p:cMediaNode vol="80000">
+                <p:cTn id="2" fill="hold" display="0">
+                  <p:stCondLst>
+                    <p:cond delay="indefinite"/>
+                  </p:stCondLst>
+                </p:cTn>
+                <p:tgtEl>
+                  <p:spTgt spid="30"/>
+                </p:tgtEl>
+              </p:cMediaNode>
+            </p:video>
+          </p:childTnLst>
+        </p:cTn>
+      </p:par>
+    </p:tnLst>
+  </p:timing>
 </p:sld>
 </file>
 

</xml_diff>